<commit_message>
Align lesson plans with their decks and drop the stale project references
The slides added to lessons 6, 7 and 10 had left their lesson plans one
slide behind, and the slide totals of lessons 6 to 10 out of date; lesson
5's notebook-3 row cited the wrong slide. Fixed in the handouts and in the
Italian translations, and the handout PDFs rebuilt.

Since 12 September the exam is one drawn exercise, with no project and
nothing handed in. Speaker notes in lessons 2 and 3, lesson 10's closing
slide and plan, two quizzes and a lesson 5 notebook still spoke of a
project, a topic deadline or a hand-in; they now say what the exam is.

Co-Authored-By: Claude Opus 5.5 <noreply@anthropic.com>
</commit_message>
<xml_diff>
--- a/Lessons/02_data_exploration_and_preparation/Slides/data_exploration_and_preparation_slides.pptx
+++ b/Lessons/02_data_exploration_and_preparation/Slides/data_exploration_and_preparation_slides.pptx
@@ -4779,7 +4779,7 @@
             </a:pPr>
             <a:r>
               <a:rPr/>
-              <a:t>If the room is moving fast, section 7 is where to slow down: ColumnTransformer is the piece they will reuse in every exercise and in the project, and getting the column selectors right is fiddlier than it looks.</a:t>
+              <a:t>If the room is moving fast, section 7 is where to slow down: ColumnTransformer is the piece they will reuse in every exercise, and getting the column selectors right is fiddlier than it looks.</a:t>
             </a:r>
           </a:p>
           <a:p>
@@ -6043,7 +6043,7 @@
             </a:pPr>
             <a:r>
               <a:rPr/>
-              <a:t>If time is short, the target encoding case is the one to keep: it is the subtlest and the one most likely to appear in their own project.</a:t>
+              <a:t>If time is short, the target encoding case is the one to keep: it is the subtlest and the one most likely to appear in their own exercises.</a:t>
             </a:r>
           </a:p>
         </p:txBody>
@@ -6373,7 +6373,7 @@
             </a:pPr>
             <a:r>
               <a:rPr/>
-              <a:t>Remind them the Lesson 1 exercise is due today if anyone has not handed it in, and that the project topic must be confirmed by Lesson 4 - which is two weeks away, so now is the time to be reading dataset descriptions.</a:t>
+              <a:t>Remind them that nothing is handed in: every exercise is kept, because one of the ten is drawn at the exam and discussed from their own notebook.</a:t>
             </a:r>
           </a:p>
         </p:txBody>

</xml_diff>

<commit_message>
Make lesson 2's notebooks ask for predictions and a seed of your own
With the course image on every laptop, students run the notebooks in the
room. Seven "Your prediction" cells now sit before the cells that reveal the
lesson's numbers - the correlation left after mean imputation, what each
outlier rule flags, learning rate 2.0 on raw features, the pipeline against
the 0.806 baseline, the 94 of 128 borrowed rows, what that leak is worth, the
AUC of an empty column - so each student commits to an answer first.

Notebook 3 gains a closing section, "Your own split": MY_SEED (birthday as
DDMM) reruns both leaks on a split of the student's own, for a tally on the
board. Its default, 7, reproduces the numbers above; every existing output is
unchanged. Speaker notes say when to use both, and notebook 3's notes no
longer claim the imputation leak inflates the score - the notebook shows it
does not, measurably.

Co-Authored-By: Claude Opus 5.5 <noreply@anthropic.com>
</commit_message>
<xml_diff>
--- a/Lessons/02_data_exploration_and_preparation/Slides/data_exploration_and_preparation_slides.pptx
+++ b/Lessons/02_data_exploration_and_preparation/Slides/data_exploration_and_preparation_slides.pptx
@@ -2079,6 +2079,20 @@
             </a:pPr>
             <a:r>
               <a:rPr/>
+              <a:t>Two cells now open with “Your prediction”: the correlation left after filling 40% with the mean, and how many points each outlier rule flags. Give them a minute to write a number in the cell before running it. The point is to commit to an answer, not to be right; the most useful wrong answer in the room is “the IQR rule, because it flagged more”.</a:t>
+            </a:r>
+          </a:p>
+          <a:p>
+            <a:pPr lvl="0" indent="0" marL="0">
+              <a:buNone/>
+            </a:pPr>
+          </a:p>
+          <a:p>
+            <a:pPr lvl="0" indent="0" marL="0">
+              <a:buNone/>
+            </a:pPr>
+            <a:r>
+              <a:rPr/>
               <a:t>Watch for the group that finishes early. Point them at the “try this” in the notebook: change the missing fraction and watch the correlation attenuate as the derivation predicts.</a:t>
             </a:r>
           </a:p>
@@ -4796,6 +4810,20 @@
               <a:t>And leave time for section 8, which is the one they will get wrong on their own data: the engineered feature gains 0.0034, then loses 0.0075 once tenure is cleaned first. Ask them why before telling them.</a:t>
             </a:r>
           </a:p>
+          <a:p>
+            <a:pPr lvl="0" indent="0" marL="0">
+              <a:buNone/>
+            </a:pPr>
+          </a:p>
+          <a:p>
+            <a:pPr lvl="0" indent="0" marL="0">
+              <a:buNone/>
+            </a:pPr>
+            <a:r>
+              <a:rPr/>
+              <a:t>Two prediction cells to give a minute each: what learning rate 2.0 does on the raw features (most expect “slower”; it oscillates for ever), and what accuracy the full pipeline reaches against the 0.806 baseline (0.820, which is the cue for why accuracy is the wrong scale here).</a:t>
+            </a:r>
+          </a:p>
         </p:txBody>
       </p:sp>
       <p:sp>
@@ -6029,7 +6057,21 @@
             </a:pPr>
             <a:r>
               <a:rPr/>
-              <a:t>The numbers matter less than the pattern - both leaks inflate the score, neither raises an error, and both are things a competent person does by accident. Ask them to predict the direction and rough size of each gap before running the cell.</a:t>
+              <a:t>The numbers matter less than the pattern - neither leak raises an error, and both are things a competent person does by accident. They differ in what they do to the score: the imputation leak contaminates 94 of 128 rows and barely moves the AUC (+0.0007, negative in 14 of 20 splits), so it cannot be caught by its effect; the encoding leak adds 0.14 out of a column with no signal. Three cells ask for a prediction first - how many rows borrow from the test set, how much that leak is worth, what AUC an empty column reaches - give each a minute.</a:t>
+            </a:r>
+          </a:p>
+          <a:p>
+            <a:pPr lvl="0" indent="0" marL="0">
+              <a:buNone/>
+            </a:pPr>
+          </a:p>
+          <a:p>
+            <a:pPr lvl="0" indent="0" marL="0">
+              <a:buNone/>
+            </a:pPr>
+            <a:r>
+              <a:rPr/>
+              <a:t>Close with section 6, five minutes: everyone sets MY_SEED to their birthday as DDMM, runs the cell and calls out the three numbers; tally them on the board. Expect leak 1 at roughly 70-80% of the rows every time, the leaky encoding always about 0.11-0.15 above the honest one, and the honest AUC itself moving between about 0.74 and 0.80 from one birthday to the next - lesson 5’s lottery, seen a week early.</a:t>
             </a:r>
           </a:p>
           <a:p>

</xml_diff>

<commit_message>
Open lesson 2 with fifteen minutes on what lesson 1 clarified
The time comes from the break, the closing recap and three lecture segments;
the notebooks keep theirs. Speaker notes follow the new timings.

Co-Authored-By: Claude Opus 5.5 <noreply@anthropic.com>
</commit_message>
<xml_diff>
--- a/Lessons/02_data_exploration_and_preparation/Slides/data_exploration_and_preparation_slides.pptx
+++ b/Lessons/02_data_exploration_and_preparation/Slides/data_exploration_and_preparation_slides.pptx
@@ -579,6 +579,20 @@
             </a:pPr>
             <a:r>
               <a:rPr/>
+              <a:t>The fifteen minutes on what lesson 1 clarified come before this slide; the exercise discussion follows them, and the seed part of it lands better for having just seen that a test score is one measurement.</a:t>
+            </a:r>
+          </a:p>
+          <a:p>
+            <a:pPr lvl="0" indent="0" marL="0">
+              <a:buNone/>
+            </a:pPr>
+          </a:p>
+          <a:p>
+            <a:pPr lvl="0" indent="0" marL="0">
+              <a:buNone/>
+            </a:pPr>
+            <a:r>
+              <a:rPr/>
               <a:t>Open with the exercise, briefly - two or three minutes, not a review session. Nothing is collected, so this is the whole of the feedback: ask for a show of hands, who treated quality as binary and who kept it as an integer regression problem. Both are defensible if justified; that was the whole point of Task 1.</a:t>
             </a:r>
           </a:p>
@@ -2175,7 +2189,7 @@
             </a:pPr>
             <a:r>
               <a:rPr/>
-              <a:t>15 minutes. Back for scaling, encoding and the pipeline.</a:t>
+              <a:t>10 minutes. Back for scaling, encoding and the pipeline.</a:t>
             </a:r>
           </a:p>
           <a:p>
@@ -3195,7 +3209,7 @@
             </a:pPr>
             <a:r>
               <a:rPr/>
-              <a:t>Timing: roughly 35 minutes to the first notebook, then a break, then scaling and encoding, then the leakage section closes the lesson before homework.</a:t>
+              <a:t>Timing: roughly 25 minutes to the first notebook, then a break, then scaling and encoding, then the leakage section closes the lesson before homework.</a:t>
             </a:r>
           </a:p>
         </p:txBody>

</xml_diff>

<commit_message>
Anchor lesson 2's slides to the code its notebooks run
Co-Authored-By: Claude Opus 5.5 <noreply@anthropic.com>
</commit_message>
<xml_diff>
--- a/Lessons/02_data_exploration_and_preparation/Slides/data_exploration_and_preparation_slides.pptx
+++ b/Lessons/02_data_exploration_and_preparation/Slides/data_exploration_and_preparation_slides.pptx
@@ -2065,6 +2065,20 @@
             </a:pPr>
             <a:r>
               <a:rPr/>
+              <a:t>Exploration, missingness mechanisms, both outlier rules: from scratch. The table is the notebook’s map - no scikit-learn yet, only the pandas calls that do the looking, each next to the slides where the idea was introduced.</a:t>
+            </a:r>
+          </a:p>
+          <a:p>
+            <a:pPr lvl="0" indent="0" marL="0">
+              <a:buNone/>
+            </a:pPr>
+          </a:p>
+          <a:p>
+            <a:pPr lvl="0" indent="0" marL="0">
+              <a:buNone/>
+            </a:pPr>
+            <a:r>
+              <a:rPr/>
               <a:t>Work through notebook 1 now, 20 minutes. Let them drive; walk the room rather than presenting.</a:t>
             </a:r>
           </a:p>
@@ -4751,6 +4765,20 @@
             </a:pPr>
             <a:r>
               <a:rPr/>
+              <a:t>The right-hand column carries the four numbers to come back with, each next to the calls that produce it. The rest of the table is the map: every scikit-learn name the notebook uses, beside the slides that introduced the idea.</a:t>
+            </a:r>
+          </a:p>
+          <a:p>
+            <a:pPr lvl="0" indent="0" marL="0">
+              <a:buNone/>
+            </a:pPr>
+          </a:p>
+          <a:p>
+            <a:pPr lvl="0" indent="0" marL="0">
+              <a:buNone/>
+            </a:pPr>
+            <a:r>
+              <a:rPr/>
               <a:t>20 minutes. Let them work; circulate.</a:t>
             </a:r>
           </a:p>
@@ -6051,6 +6079,20 @@
         <p:txBody>
           <a:bodyPr/>
           <a:lstStyle/>
+          <a:p>
+            <a:pPr lvl="0" indent="0" marL="0">
+              <a:buNone/>
+            </a:pPr>
+            <a:r>
+              <a:rPr/>
+              <a:t>Trace the imputation leak. Watch the encoding leak manufacture 0.89 from noise. The table puts each leak beside the calls that commit it and the slides that explain it; the fix row is the one to leave on screen.</a:t>
+            </a:r>
+          </a:p>
+          <a:p>
+            <a:pPr lvl="0" indent="0" marL="0">
+              <a:buNone/>
+            </a:pPr>
+          </a:p>
           <a:p>
             <a:pPr lvl="0" indent="0" marL="0">
               <a:buNone/>
@@ -10440,7 +10482,17 @@
             </a:r>
             <a:r>
               <a:rPr/>
-              <a:t>: mean/median, most-frequent, </a:t>
+              <a:t>: mean/median or most-frequent with </a:t>
+            </a:r>
+            <a:r>
+              <a:rPr>
+                <a:latin typeface="Courier"/>
+              </a:rPr>
+              <a:t>SimpleImputer</a:t>
+            </a:r>
+            <a:r>
+              <a:rPr/>
+              <a:t>, neighbours with </a:t>
             </a:r>
             <a:r>
               <a:rPr>
@@ -11450,36 +11502,286 @@
           </a:p>
         </p:txBody>
       </p:sp>
-      <p:sp>
-        <p:nvSpPr>
-          <p:cNvPr id="3" name="Content Placeholder 2"/>
-          <p:cNvSpPr>
-            <a:spLocks noGrp="1"/>
-          </p:cNvSpPr>
+      <p:graphicFrame>
+        <p:nvGraphicFramePr>
+          <p:cNvPr id="6" name="Content Placeholder 5"/>
+          <p:cNvGraphicFramePr>
+            <a:graphicFrameLocks noGrp="1"/>
+          </p:cNvGraphicFramePr>
           <p:nvPr>
             <p:ph idx="1"/>
           </p:nvPr>
-        </p:nvSpPr>
-        <p:spPr>
-          <a:xfrm>
-            <a:off x="457200" y="1200151"/>
-            <a:ext cx="8229600" cy="3394472"/>
-          </a:xfrm>
-        </p:spPr>
-        <p:txBody>
-          <a:bodyPr/>
-          <a:lstStyle/>
-          <a:p>
-            <a:pPr lvl="0" indent="0" marL="0">
-              <a:buNone/>
-            </a:pPr>
-            <a:r>
-              <a:rPr/>
-              <a:t>Exploration, missingness mechanisms, both outlier rules: from scratch.</a:t>
-            </a:r>
-          </a:p>
-        </p:txBody>
-      </p:sp>
+        </p:nvGraphicFramePr>
+        <p:xfrm>
+          <a:off x="457200" y="1166099"/>
+          <a:ext cx="8229600" cy="3390900"/>
+        </p:xfrm>
+        <a:graphic>
+          <a:graphicData uri="http://schemas.openxmlformats.org/drawingml/2006/table">
+            <a:tbl>
+              <a:tblPr firstRow="1" bandRow="1">
+                <a:tableStyleId>{5C22544A-7EE6-4342-B048-85BDC9FD1C3A}</a:tableStyleId>
+              </a:tblPr>
+              <a:tblGrid>
+                <a:gridCol w="4114800"/>
+                <a:gridCol w="4114800"/>
+              </a:tblGrid>
+              <a:tr h="0">
+                <a:tc>
+                  <a:txBody>
+                    <a:bodyPr/>
+                    <a:lstStyle/>
+                    <a:p>
+                      <a:pPr lvl="0" indent="0" marL="0">
+                        <a:buNone/>
+                      </a:pPr>
+                      <a:r>
+                        <a:rPr/>
+                        <a:t>section, and its slides</a:t>
+                      </a:r>
+                    </a:p>
+                  </a:txBody>
+                  <a:tcPr/>
+                </a:tc>
+                <a:tc>
+                  <a:txBody>
+                    <a:bodyPr/>
+                    <a:lstStyle/>
+                    <a:p>
+                      <a:pPr lvl="0" indent="0" marL="0">
+                        <a:buNone/>
+                      </a:pPr>
+                      <a:r>
+                        <a:rPr/>
+                        <a:t>you call (pandas, no model yet)</a:t>
+                      </a:r>
+                    </a:p>
+                  </a:txBody>
+                  <a:tcPr/>
+                </a:tc>
+              </a:tr>
+              <a:tr h="0">
+                <a:tc>
+                  <a:txBody>
+                    <a:bodyPr/>
+                    <a:lstStyle/>
+                    <a:p>
+                      <a:pPr lvl="0" indent="0" marL="0">
+                        <a:buNone/>
+                      </a:pPr>
+                      <a:r>
+                        <a:rPr/>
+                        <a:t>first look, 6</a:t>
+                      </a:r>
+                    </a:p>
+                  </a:txBody>
+                </a:tc>
+                <a:tc>
+                  <a:txBody>
+                    <a:bodyPr/>
+                    <a:lstStyle/>
+                    <a:p>
+                      <a:pPr lvl="0" indent="0" marL="0">
+                        <a:buNone/>
+                      </a:pPr>
+                      <a:r>
+                        <a:rPr>
+                          <a:latin typeface="Courier"/>
+                        </a:rPr>
+                        <a:t>df.info()</a:t>
+                      </a:r>
+                      <a:r>
+                        <a:rPr/>
+                        <a:t>, </a:t>
+                      </a:r>
+                      <a:r>
+                        <a:rPr>
+                          <a:latin typeface="Courier"/>
+                        </a:rPr>
+                        <a:t>df.describe()</a:t>
+                      </a:r>
+                    </a:p>
+                  </a:txBody>
+                </a:tc>
+              </a:tr>
+              <a:tr h="0">
+                <a:tc>
+                  <a:txBody>
+                    <a:bodyPr/>
+                    <a:lstStyle/>
+                    <a:p>
+                      <a:pPr lvl="0" indent="0" marL="0">
+                        <a:buNone/>
+                      </a:pPr>
+                      <a:r>
+                        <a:rPr/>
+                        <a:t>distributions, 7</a:t>
+                      </a:r>
+                    </a:p>
+                  </a:txBody>
+                </a:tc>
+                <a:tc>
+                  <a:txBody>
+                    <a:bodyPr/>
+                    <a:lstStyle/>
+                    <a:p>
+                      <a:pPr lvl="0" indent="0" marL="0">
+                        <a:buNone/>
+                      </a:pPr>
+                      <a:r>
+                        <a:rPr>
+                          <a:latin typeface="Courier"/>
+                        </a:rPr>
+                        <a:t>df.hist()</a:t>
+                      </a:r>
+                    </a:p>
+                  </a:txBody>
+                </a:tc>
+              </a:tr>
+              <a:tr h="0">
+                <a:tc>
+                  <a:txBody>
+                    <a:bodyPr/>
+                    <a:lstStyle/>
+                    <a:p>
+                      <a:pPr lvl="0" indent="0" marL="0">
+                        <a:buNone/>
+                      </a:pPr>
+                      <a:r>
+                        <a:rPr/>
+                        <a:t>missingness, 8-12</a:t>
+                      </a:r>
+                    </a:p>
+                  </a:txBody>
+                </a:tc>
+                <a:tc>
+                  <a:txBody>
+                    <a:bodyPr/>
+                    <a:lstStyle/>
+                    <a:p>
+                      <a:pPr lvl="0" indent="0" marL="0">
+                        <a:buNone/>
+                      </a:pPr>
+                      <a:r>
+                        <a:rPr>
+                          <a:latin typeface="Courier"/>
+                        </a:rPr>
+                        <a:t>df.isna().mean()</a:t>
+                      </a:r>
+                      <a:r>
+                        <a:rPr/>
+                        <a:t>, and the mean before and after filling</a:t>
+                      </a:r>
+                    </a:p>
+                  </a:txBody>
+                </a:tc>
+              </a:tr>
+              <a:tr h="0">
+                <a:tc>
+                  <a:txBody>
+                    <a:bodyPr/>
+                    <a:lstStyle/>
+                    <a:p>
+                      <a:pPr lvl="0" indent="0" marL="0">
+                        <a:buNone/>
+                      </a:pPr>
+                      <a:r>
+                        <a:rPr/>
+                        <a:t>outliers from scratch, 15-19</a:t>
+                      </a:r>
+                    </a:p>
+                  </a:txBody>
+                </a:tc>
+                <a:tc>
+                  <a:txBody>
+                    <a:bodyPr/>
+                    <a:lstStyle/>
+                    <a:p>
+                      <a:pPr lvl="0" indent="0" marL="0">
+                        <a:buNone/>
+                      </a:pPr>
+                      <a:r>
+                        <a:rPr>
+                          <a:latin typeface="Courier"/>
+                        </a:rPr>
+                        <a:t>.mean()</a:t>
+                      </a:r>
+                      <a:r>
+                        <a:rPr/>
+                        <a:t> and </a:t>
+                      </a:r>
+                      <a:r>
+                        <a:rPr>
+                          <a:latin typeface="Courier"/>
+                        </a:rPr>
+                        <a:t>.std()</a:t>
+                      </a:r>
+                      <a:r>
+                        <a:rPr/>
+                        <a:t> for rule 1, </a:t>
+                      </a:r>
+                      <a:r>
+                        <a:rPr>
+                          <a:latin typeface="Courier"/>
+                        </a:rPr>
+                        <a:t>.quantile([0.25, 0.75])</a:t>
+                      </a:r>
+                      <a:r>
+                        <a:rPr/>
+                        <a:t> for rule 2</a:t>
+                      </a:r>
+                    </a:p>
+                  </a:txBody>
+                </a:tc>
+              </a:tr>
+              <a:tr h="0">
+                <a:tc>
+                  <a:txBody>
+                    <a:bodyPr/>
+                    <a:lstStyle/>
+                    <a:p>
+                      <a:pPr lvl="0" indent="0" marL="0">
+                        <a:buNone/>
+                      </a:pPr>
+                      <a:r>
+                        <a:rPr/>
+                        <a:t>correlations, categories</a:t>
+                      </a:r>
+                    </a:p>
+                  </a:txBody>
+                </a:tc>
+                <a:tc>
+                  <a:txBody>
+                    <a:bodyPr/>
+                    <a:lstStyle/>
+                    <a:p>
+                      <a:pPr lvl="0" indent="0" marL="0">
+                        <a:buNone/>
+                      </a:pPr>
+                      <a:r>
+                        <a:rPr>
+                          <a:latin typeface="Courier"/>
+                        </a:rPr>
+                        <a:t>df.corr()</a:t>
+                      </a:r>
+                      <a:r>
+                        <a:rPr/>
+                        <a:t>, </a:t>
+                      </a:r>
+                      <a:r>
+                        <a:rPr>
+                          <a:latin typeface="Courier"/>
+                        </a:rPr>
+                        <a:t>.value_counts()</a:t>
+                      </a:r>
+                    </a:p>
+                  </a:txBody>
+                </a:tc>
+              </a:tr>
+            </a:tbl>
+          </a:graphicData>
+        </a:graphic>
+      </p:graphicFrame>
     </p:spTree>
   </p:cSld>
 </p:sld>
@@ -12804,7 +13106,13 @@
             <a:pPr lvl="0"/>
             <a:r>
               <a:rPr/>
-              <a:t>A column with k levels becomes k binary columns, one 1 per row</a:t>
+              <a:t>A column with k levels becomes k binary columns, one 1 per row: </a:t>
+            </a:r>
+            <a:r>
+              <a:rPr>
+                <a:latin typeface="Courier"/>
+              </a:rPr>
+              <a:t>OneHotEncoder</a:t>
             </a:r>
           </a:p>
           <a:p>
@@ -13796,6 +14104,39 @@
             </a:r>
           </a:p>
           <a:p>
+            <a:pPr lvl="0"/>
+            <a:r>
+              <a:rPr/>
+              <a:t>In code: </a:t>
+            </a:r>
+            <a:r>
+              <a:rPr>
+                <a:latin typeface="Courier"/>
+              </a:rPr>
+              <a:t>LogisticRegression</a:t>
+            </a:r>
+            <a:r>
+              <a:rPr/>
+              <a:t> against </a:t>
+            </a:r>
+            <a:r>
+              <a:rPr>
+                <a:latin typeface="Courier"/>
+              </a:rPr>
+              <a:t>DummyClassifier</a:t>
+            </a:r>
+            <a:r>
+              <a:rPr/>
+              <a:t>; AUC from </a:t>
+            </a:r>
+            <a:r>
+              <a:rPr>
+                <a:latin typeface="Courier"/>
+              </a:rPr>
+              <a:t>roc_auc_score</a:t>
+            </a:r>
+          </a:p>
+          <a:p>
             <a:pPr lvl="0" indent="0" marL="0">
               <a:buNone/>
             </a:pPr>
@@ -14116,6 +14457,25 @@
               <a:t> - the gain was living in the 999s.</a:t>
             </a:r>
           </a:p>
+          <a:p>
+            <a:pPr lvl="0" indent="0" marL="0">
+              <a:buNone/>
+            </a:pPr>
+            <a:r>
+              <a:rPr/>
+              <a:t>In code: </a:t>
+            </a:r>
+            <a:r>
+              <a:rPr>
+                <a:latin typeface="Courier"/>
+              </a:rPr>
+              <a:t>FunctionTransformer(add_total_paid)</a:t>
+            </a:r>
+            <a:r>
+              <a:rPr/>
+              <a:t>, a step inside the pipeline</a:t>
+            </a:r>
+          </a:p>
         </p:txBody>
       </p:sp>
     </p:spTree>
@@ -14170,120 +14530,380 @@
           </a:p>
         </p:txBody>
       </p:sp>
-      <p:sp>
-        <p:nvSpPr>
-          <p:cNvPr id="3" name="Content Placeholder 2"/>
-          <p:cNvSpPr>
-            <a:spLocks noGrp="1"/>
-          </p:cNvSpPr>
+      <p:graphicFrame>
+        <p:nvGraphicFramePr>
+          <p:cNvPr id="6" name="Content Placeholder 5"/>
+          <p:cNvGraphicFramePr>
+            <a:graphicFrameLocks noGrp="1"/>
+          </p:cNvGraphicFramePr>
           <p:nvPr>
             <p:ph idx="1"/>
           </p:nvPr>
-        </p:nvSpPr>
-        <p:spPr>
-          <a:xfrm>
-            <a:off x="457200" y="1200151"/>
-            <a:ext cx="8229600" cy="3394472"/>
-          </a:xfrm>
-        </p:spPr>
-        <p:txBody>
-          <a:bodyPr/>
-          <a:lstStyle/>
-          <a:p>
-            <a:pPr lvl="0" indent="0" marL="0">
-              <a:buNone/>
-            </a:pPr>
-            <a:r>
-              <a:rPr/>
-              <a:t>Four numbers to come back with:</a:t>
-            </a:r>
-          </a:p>
-          <a:p>
-            <a:pPr lvl="0"/>
-            <a:r>
-              <a:rPr/>
-              <a:t>Variance ratio </a:t>
-            </a:r>
-            <a:r>
-              <a:rPr b="1"/>
-              <a:t>110:1</a:t>
-            </a:r>
-            <a:r>
-              <a:rPr/>
-              <a:t> - learning rate </a:t>
-            </a:r>
-            <a:r>
-              <a:rPr b="1"/>
-              <a:t>2.0</a:t>
-            </a:r>
-            <a:r>
-              <a:rPr/>
-              <a:t> scaled, </a:t>
-            </a:r>
-            <a:r>
-              <a:rPr b="1"/>
-              <a:t>0.1</a:t>
-            </a:r>
-            <a:r>
-              <a:rPr/>
-              <a:t> raw</a:t>
-            </a:r>
-          </a:p>
-          <a:p>
-            <a:pPr lvl="0"/>
-            <a:r>
-              <a:rPr/>
-              <a:t>That rate on raw features: loss swings </a:t>
-            </a:r>
-            <a:r>
-              <a:rPr b="1"/>
-              <a:t>0.69 to 8.29</a:t>
-            </a:r>
-            <a:r>
-              <a:rPr/>
-              <a:t>, for ever</a:t>
-            </a:r>
-          </a:p>
-          <a:p>
-            <a:pPr lvl="0"/>
-            <a:r>
-              <a:rPr/>
-              <a:t>k dummies + intercept: </a:t>
-            </a:r>
-            <a:r>
-              <a:rPr b="1"/>
-              <a:t>4 columns, rank 3</a:t>
-            </a:r>
-          </a:p>
-          <a:p>
-            <a:pPr lvl="0"/>
-            <a:r>
-              <a:rPr>
-                <a:latin typeface="Courier"/>
-              </a:rPr>
-              <a:t>Pipeline</a:t>
-            </a:r>
-            <a:r>
-              <a:rPr/>
-              <a:t>, then </a:t>
-            </a:r>
-            <a:r>
-              <a:rPr>
-                <a:latin typeface="Courier"/>
-              </a:rPr>
-              <a:t>total_paid</a:t>
-            </a:r>
-            <a:r>
-              <a:rPr/>
-              <a:t>: </a:t>
-            </a:r>
-            <a:r>
-              <a:rPr b="1"/>
-              <a:t>0.7514 → 0.7548 → 0.7439</a:t>
-            </a:r>
-          </a:p>
-        </p:txBody>
-      </p:sp>
+        </p:nvGraphicFramePr>
+        <p:xfrm>
+          <a:off x="457200" y="1166099"/>
+          <a:ext cx="8229600" cy="3390900"/>
+        </p:xfrm>
+        <a:graphic>
+          <a:graphicData uri="http://schemas.openxmlformats.org/drawingml/2006/table">
+            <a:tbl>
+              <a:tblPr firstRow="1" bandRow="1">
+                <a:tableStyleId>{5C22544A-7EE6-4342-B048-85BDC9FD1C3A}</a:tableStyleId>
+              </a:tblPr>
+              <a:tblGrid>
+                <a:gridCol w="4114800"/>
+                <a:gridCol w="4114800"/>
+              </a:tblGrid>
+              <a:tr h="0">
+                <a:tc>
+                  <a:txBody>
+                    <a:bodyPr/>
+                    <a:lstStyle/>
+                    <a:p>
+                      <a:pPr lvl="0" indent="0" marL="0">
+                        <a:buNone/>
+                      </a:pPr>
+                      <a:r>
+                        <a:rPr/>
+                        <a:t>section, and its slides</a:t>
+                      </a:r>
+                    </a:p>
+                  </a:txBody>
+                  <a:tcPr/>
+                </a:tc>
+                <a:tc>
+                  <a:txBody>
+                    <a:bodyPr/>
+                    <a:lstStyle/>
+                    <a:p>
+                      <a:pPr lvl="0" indent="0" marL="0">
+                        <a:buNone/>
+                      </a:pPr>
+                      <a:r>
+                        <a:rPr/>
+                        <a:t>you call → the number to come back with</a:t>
+                      </a:r>
+                    </a:p>
+                  </a:txBody>
+                  <a:tcPr/>
+                </a:tc>
+              </a:tr>
+              <a:tr h="0">
+                <a:tc>
+                  <a:txBody>
+                    <a:bodyPr/>
+                    <a:lstStyle/>
+                    <a:p>
+                      <a:pPr lvl="0" indent="0" marL="0">
+                        <a:buNone/>
+                      </a:pPr>
+                      <a:r>
+                        <a:rPr/>
+                        <a:t>why scale, 24-27</a:t>
+                      </a:r>
+                    </a:p>
+                  </a:txBody>
+                </a:tc>
+                <a:tc>
+                  <a:txBody>
+                    <a:bodyPr/>
+                    <a:lstStyle/>
+                    <a:p>
+                      <a:pPr lvl="0" indent="0" marL="0">
+                        <a:buNone/>
+                      </a:pPr>
+                      <a:r>
+                        <a:rPr/>
+                        <a:t>gradient descent by hand → ratio </a:t>
+                      </a:r>
+                      <a:r>
+                        <a:rPr b="1"/>
+                        <a:t>110:1</a:t>
+                      </a:r>
+                      <a:r>
+                        <a:rPr/>
+                        <a:t>; rate </a:t>
+                      </a:r>
+                      <a:r>
+                        <a:rPr b="1"/>
+                        <a:t>2.0</a:t>
+                      </a:r>
+                      <a:r>
+                        <a:rPr/>
+                        <a:t> scaled, </a:t>
+                      </a:r>
+                      <a:r>
+                        <a:rPr b="1"/>
+                        <a:t>0.1</a:t>
+                      </a:r>
+                      <a:r>
+                        <a:rPr/>
+                        <a:t> raw; raw at 2.0 swings </a:t>
+                      </a:r>
+                      <a:r>
+                        <a:rPr b="1"/>
+                        <a:t>0.69 to 8.29</a:t>
+                      </a:r>
+                    </a:p>
+                  </a:txBody>
+                </a:tc>
+              </a:tr>
+              <a:tr h="0">
+                <a:tc>
+                  <a:txBody>
+                    <a:bodyPr/>
+                    <a:lstStyle/>
+                    <a:p>
+                      <a:pPr lvl="0" indent="0" marL="0">
+                        <a:buNone/>
+                      </a:pPr>
+                      <a:r>
+                        <a:rPr/>
+                        <a:t>encoding, 28-33</a:t>
+                      </a:r>
+                    </a:p>
+                  </a:txBody>
+                </a:tc>
+                <a:tc>
+                  <a:txBody>
+                    <a:bodyPr/>
+                    <a:lstStyle/>
+                    <a:p>
+                      <a:pPr lvl="0" indent="0" marL="0">
+                        <a:buNone/>
+                      </a:pPr>
+                      <a:r>
+                        <a:rPr>
+                          <a:latin typeface="Courier"/>
+                        </a:rPr>
+                        <a:t>pd.get_dummies</a:t>
+                      </a:r>
+                      <a:r>
+                        <a:rPr/>
+                        <a:t>, </a:t>
+                      </a:r>
+                      <a:r>
+                        <a:rPr>
+                          <a:latin typeface="Courier"/>
+                        </a:rPr>
+                        <a:t>np.linalg.matrix_rank</a:t>
+                      </a:r>
+                      <a:r>
+                        <a:rPr/>
+                        <a:t> → </a:t>
+                      </a:r>
+                      <a:r>
+                        <a:rPr b="1"/>
+                        <a:t>4 columns, rank 3</a:t>
+                      </a:r>
+                    </a:p>
+                  </a:txBody>
+                </a:tc>
+              </a:tr>
+              <a:tr h="0">
+                <a:tc>
+                  <a:txBody>
+                    <a:bodyPr/>
+                    <a:lstStyle/>
+                    <a:p>
+                      <a:pPr lvl="0" indent="0" marL="0">
+                        <a:buNone/>
+                      </a:pPr>
+                      <a:r>
+                        <a:rPr/>
+                        <a:t>the pipeline, 36-38</a:t>
+                      </a:r>
+                    </a:p>
+                  </a:txBody>
+                </a:tc>
+                <a:tc>
+                  <a:txBody>
+                    <a:bodyPr/>
+                    <a:lstStyle/>
+                    <a:p>
+                      <a:pPr lvl="0" indent="0" marL="0">
+                        <a:buNone/>
+                      </a:pPr>
+                      <a:r>
+                        <a:rPr>
+                          <a:latin typeface="Courier"/>
+                        </a:rPr>
+                        <a:t>train_test_split</a:t>
+                      </a:r>
+                      <a:r>
+                        <a:rPr/>
+                        <a:t>, then </a:t>
+                      </a:r>
+                      <a:r>
+                        <a:rPr>
+                          <a:latin typeface="Courier"/>
+                        </a:rPr>
+                        <a:t>ColumnTransformer</a:t>
+                      </a:r>
+                      <a:r>
+                        <a:rPr/>
+                        <a:t> + </a:t>
+                      </a:r>
+                      <a:r>
+                        <a:rPr>
+                          <a:latin typeface="Courier"/>
+                        </a:rPr>
+                        <a:t>Pipeline</a:t>
+                      </a:r>
+                      <a:r>
+                        <a:rPr/>
+                        <a:t>: </a:t>
+                      </a:r>
+                      <a:r>
+                        <a:rPr>
+                          <a:latin typeface="Courier"/>
+                        </a:rPr>
+                        <a:t>SimpleImputer</a:t>
+                      </a:r>
+                      <a:r>
+                        <a:rPr/>
+                        <a:t>, </a:t>
+                      </a:r>
+                      <a:r>
+                        <a:rPr>
+                          <a:latin typeface="Courier"/>
+                        </a:rPr>
+                        <a:t>StandardScaler</a:t>
+                      </a:r>
+                      <a:r>
+                        <a:rPr/>
+                        <a:t>, </a:t>
+                      </a:r>
+                      <a:r>
+                        <a:rPr>
+                          <a:latin typeface="Courier"/>
+                        </a:rPr>
+                        <a:t>OneHotEncoder</a:t>
+                      </a:r>
+                      <a:r>
+                        <a:rPr/>
+                        <a:t>, </a:t>
+                      </a:r>
+                      <a:r>
+                        <a:rPr>
+                          <a:latin typeface="Courier"/>
+                        </a:rPr>
+                        <a:t>LogisticRegression</a:t>
+                      </a:r>
+                    </a:p>
+                  </a:txBody>
+                </a:tc>
+              </a:tr>
+              <a:tr h="0">
+                <a:tc>
+                  <a:txBody>
+                    <a:bodyPr/>
+                    <a:lstStyle/>
+                    <a:p>
+                      <a:pPr lvl="0" indent="0" marL="0">
+                        <a:buNone/>
+                      </a:pPr>
+                      <a:r>
+                        <a:rPr/>
+                        <a:t>the result, 39-40</a:t>
+                      </a:r>
+                    </a:p>
+                  </a:txBody>
+                </a:tc>
+                <a:tc>
+                  <a:txBody>
+                    <a:bodyPr/>
+                    <a:lstStyle/>
+                    <a:p>
+                      <a:pPr lvl="0" indent="0" marL="0">
+                        <a:buNone/>
+                      </a:pPr>
+                      <a:r>
+                        <a:rPr>
+                          <a:latin typeface="Courier"/>
+                        </a:rPr>
+                        <a:t>DummyClassifier</a:t>
+                      </a:r>
+                      <a:r>
+                        <a:rPr/>
+                        <a:t>, </a:t>
+                      </a:r>
+                      <a:r>
+                        <a:rPr>
+                          <a:latin typeface="Courier"/>
+                        </a:rPr>
+                        <a:t>accuracy_score</a:t>
+                      </a:r>
+                      <a:r>
+                        <a:rPr/>
+                        <a:t>, </a:t>
+                      </a:r>
+                      <a:r>
+                        <a:rPr>
+                          <a:latin typeface="Courier"/>
+                        </a:rPr>
+                        <a:t>roc_auc_score</a:t>
+                      </a:r>
+                      <a:r>
+                        <a:rPr/>
+                        <a:t>, </a:t>
+                      </a:r>
+                      <a:r>
+                        <a:rPr>
+                          <a:latin typeface="Courier"/>
+                        </a:rPr>
+                        <a:t>ConfusionMatrixDisplay</a:t>
+                      </a:r>
+                    </a:p>
+                  </a:txBody>
+                </a:tc>
+              </a:tr>
+              <a:tr h="0">
+                <a:tc>
+                  <a:txBody>
+                    <a:bodyPr/>
+                    <a:lstStyle/>
+                    <a:p>
+                      <a:pPr lvl="0" indent="0" marL="0">
+                        <a:buNone/>
+                      </a:pPr>
+                      <a:r>
+                        <a:rPr/>
+                        <a:t>feature engineering, 41</a:t>
+                      </a:r>
+                    </a:p>
+                  </a:txBody>
+                </a:tc>
+                <a:tc>
+                  <a:txBody>
+                    <a:bodyPr/>
+                    <a:lstStyle/>
+                    <a:p>
+                      <a:pPr lvl="0" indent="0" marL="0">
+                        <a:buNone/>
+                      </a:pPr>
+                      <a:r>
+                        <a:rPr>
+                          <a:latin typeface="Courier"/>
+                        </a:rPr>
+                        <a:t>FunctionTransformer</a:t>
+                      </a:r>
+                      <a:r>
+                        <a:rPr/>
+                        <a:t> → </a:t>
+                      </a:r>
+                      <a:r>
+                        <a:rPr b="1"/>
+                        <a:t>0.7514 → 0.7548 → 0.7439</a:t>
+                      </a:r>
+                    </a:p>
+                  </a:txBody>
+                </a:tc>
+              </a:tr>
+            </a:tbl>
+          </a:graphicData>
+        </a:graphic>
+      </p:graphicFrame>
     </p:spTree>
   </p:cSld>
 </p:sld>
@@ -14569,6 +15189,25 @@
             </a:pPr>
             <a:r>
               <a:rPr/>
+              <a:t>In code: </a:t>
+            </a:r>
+            <a:r>
+              <a:rPr>
+                <a:latin typeface="Courier"/>
+              </a:rPr>
+              <a:t>nan_euclidean_distances</a:t>
+            </a:r>
+            <a:r>
+              <a:rPr/>
+              <a:t>, the imputer’s own metric, names the donors.</a:t>
+            </a:r>
+          </a:p>
+          <a:p>
+            <a:pPr lvl="0" indent="0" marL="0">
+              <a:buNone/>
+            </a:pPr>
+            <a:r>
+              <a:rPr/>
               <a:t>Nothing raised an error.</a:t>
             </a:r>
           </a:p>
@@ -15373,36 +16012,308 @@
           </a:p>
         </p:txBody>
       </p:sp>
-      <p:sp>
-        <p:nvSpPr>
-          <p:cNvPr id="3" name="Content Placeholder 2"/>
-          <p:cNvSpPr>
-            <a:spLocks noGrp="1"/>
-          </p:cNvSpPr>
+      <p:graphicFrame>
+        <p:nvGraphicFramePr>
+          <p:cNvPr id="6" name="Content Placeholder 5"/>
+          <p:cNvGraphicFramePr>
+            <a:graphicFrameLocks noGrp="1"/>
+          </p:cNvGraphicFramePr>
           <p:nvPr>
             <p:ph idx="1"/>
           </p:nvPr>
-        </p:nvSpPr>
-        <p:spPr>
-          <a:xfrm>
-            <a:off x="457200" y="1200151"/>
-            <a:ext cx="8229600" cy="3394472"/>
-          </a:xfrm>
-        </p:spPr>
-        <p:txBody>
-          <a:bodyPr/>
-          <a:lstStyle/>
-          <a:p>
-            <a:pPr lvl="0" indent="0" marL="0">
-              <a:buNone/>
-            </a:pPr>
-            <a:r>
-              <a:rPr/>
-              <a:t>Trace the imputation leak. Watch the encoding leak manufacture 0.89 from noise.</a:t>
-            </a:r>
-          </a:p>
-        </p:txBody>
-      </p:sp>
+        </p:nvGraphicFramePr>
+        <p:xfrm>
+          <a:off x="457200" y="1166099"/>
+          <a:ext cx="8229600" cy="3390900"/>
+        </p:xfrm>
+        <a:graphic>
+          <a:graphicData uri="http://schemas.openxmlformats.org/drawingml/2006/table">
+            <a:tbl>
+              <a:tblPr firstRow="1" bandRow="1">
+                <a:tableStyleId>{5C22544A-7EE6-4342-B048-85BDC9FD1C3A}</a:tableStyleId>
+              </a:tblPr>
+              <a:tblGrid>
+                <a:gridCol w="4114800"/>
+                <a:gridCol w="4114800"/>
+              </a:tblGrid>
+              <a:tr h="0">
+                <a:tc>
+                  <a:txBody>
+                    <a:bodyPr/>
+                    <a:lstStyle/>
+                    <a:p>
+                      <a:pPr lvl="0" indent="0" marL="0">
+                        <a:buNone/>
+                      </a:pPr>
+                      <a:r>
+                        <a:rPr/>
+                        <a:t>leak, and its slides</a:t>
+                      </a:r>
+                    </a:p>
+                  </a:txBody>
+                  <a:tcPr/>
+                </a:tc>
+                <a:tc>
+                  <a:txBody>
+                    <a:bodyPr/>
+                    <a:lstStyle/>
+                    <a:p>
+                      <a:pPr lvl="0" indent="0" marL="0">
+                        <a:buNone/>
+                      </a:pPr>
+                      <a:r>
+                        <a:rPr/>
+                        <a:t>you call → what it shows</a:t>
+                      </a:r>
+                    </a:p>
+                  </a:txBody>
+                  <a:tcPr/>
+                </a:tc>
+              </a:tr>
+              <a:tr h="0">
+                <a:tc>
+                  <a:txBody>
+                    <a:bodyPr/>
+                    <a:lstStyle/>
+                    <a:p>
+                      <a:pPr lvl="0" indent="0" marL="0">
+                        <a:buNone/>
+                      </a:pPr>
+                      <a:r>
+                        <a:rPr/>
+                        <a:t>imputation, 44-46</a:t>
+                      </a:r>
+                    </a:p>
+                  </a:txBody>
+                </a:tc>
+                <a:tc>
+                  <a:txBody>
+                    <a:bodyPr/>
+                    <a:lstStyle/>
+                    <a:p>
+                      <a:pPr lvl="0" indent="0" marL="0">
+                        <a:buNone/>
+                      </a:pPr>
+                      <a:r>
+                        <a:rPr>
+                          <a:latin typeface="Courier"/>
+                        </a:rPr>
+                        <a:t>KNNImputer</a:t>
+                      </a:r>
+                      <a:r>
+                        <a:rPr/>
+                        <a:t> fitted on every row; </a:t>
+                      </a:r>
+                      <a:r>
+                        <a:rPr>
+                          <a:latin typeface="Courier"/>
+                        </a:rPr>
+                        <a:t>nan_euclidean_distances</a:t>
+                      </a:r>
+                      <a:r>
+                        <a:rPr/>
+                        <a:t>, its own metric, names the donors → </a:t>
+                      </a:r>
+                      <a:r>
+                        <a:rPr b="1"/>
+                        <a:t>94 of 128</a:t>
+                      </a:r>
+                    </a:p>
+                  </a:txBody>
+                </a:tc>
+              </a:tr>
+              <a:tr h="0">
+                <a:tc>
+                  <a:txBody>
+                    <a:bodyPr/>
+                    <a:lstStyle/>
+                    <a:p>
+                      <a:pPr lvl="0" indent="0" marL="0">
+                        <a:buNone/>
+                      </a:pPr>
+                      <a:r>
+                        <a:rPr/>
+                        <a:t>encoding, 47-50</a:t>
+                      </a:r>
+                    </a:p>
+                  </a:txBody>
+                </a:tc>
+                <a:tc>
+                  <a:txBody>
+                    <a:bodyPr/>
+                    <a:lstStyle/>
+                    <a:p>
+                      <a:pPr lvl="0" indent="0" marL="0">
+                        <a:buNone/>
+                      </a:pPr>
+                      <a:r>
+                        <a:rPr/>
+                        <a:t>churn rate per </a:t>
+                      </a:r>
+                      <a:r>
+                        <a:rPr>
+                          <a:latin typeface="Courier"/>
+                        </a:rPr>
+                        <a:t>zip_code</a:t>
+                      </a:r>
+                      <a:r>
+                        <a:rPr/>
+                        <a:t>, before </a:t>
+                      </a:r>
+                      <a:r>
+                        <a:rPr>
+                          <a:latin typeface="Courier"/>
+                        </a:rPr>
+                        <a:t>train_test_split</a:t>
+                      </a:r>
+                      <a:r>
+                        <a:rPr/>
+                        <a:t> → AUC </a:t>
+                      </a:r>
+                      <a:r>
+                        <a:rPr b="1"/>
+                        <a:t>0.891</a:t>
+                      </a:r>
+                      <a:r>
+                        <a:rPr/>
+                        <a:t> from a column with no signal</a:t>
+                      </a:r>
+                    </a:p>
+                  </a:txBody>
+                </a:tc>
+              </a:tr>
+              <a:tr h="0">
+                <a:tc>
+                  <a:txBody>
+                    <a:bodyPr/>
+                    <a:lstStyle/>
+                    <a:p>
+                      <a:pPr lvl="0" indent="0" marL="0">
+                        <a:buNone/>
+                      </a:pPr>
+                      <a:r>
+                        <a:rPr/>
+                        <a:t>the fix, 51</a:t>
+                      </a:r>
+                    </a:p>
+                  </a:txBody>
+                </a:tc>
+                <a:tc>
+                  <a:txBody>
+                    <a:bodyPr/>
+                    <a:lstStyle/>
+                    <a:p>
+                      <a:pPr lvl="0" indent="0" marL="0">
+                        <a:buNone/>
+                      </a:pPr>
+                      <a:r>
+                        <a:rPr>
+                          <a:latin typeface="Courier"/>
+                        </a:rPr>
+                        <a:t>TargetEncoder</a:t>
+                      </a:r>
+                      <a:r>
+                        <a:rPr/>
+                        <a:t> inside the </a:t>
+                      </a:r>
+                      <a:r>
+                        <a:rPr>
+                          <a:latin typeface="Courier"/>
+                        </a:rPr>
+                        <a:t>ColumnTransformer</a:t>
+                      </a:r>
+                      <a:r>
+                        <a:rPr/>
+                        <a:t> → the honest </a:t>
+                      </a:r>
+                      <a:r>
+                        <a:rPr b="1"/>
+                        <a:t>0.751</a:t>
+                      </a:r>
+                    </a:p>
+                  </a:txBody>
+                </a:tc>
+              </a:tr>
+              <a:tr h="0">
+                <a:tc>
+                  <a:txBody>
+                    <a:bodyPr/>
+                    <a:lstStyle/>
+                    <a:p>
+                      <a:pPr lvl="0" indent="0" marL="0">
+                        <a:buNone/>
+                      </a:pPr>
+                      <a:r>
+                        <a:rPr/>
+                        <a:t>your own split</a:t>
+                      </a:r>
+                    </a:p>
+                  </a:txBody>
+                </a:tc>
+                <a:tc>
+                  <a:txBody>
+                    <a:bodyPr/>
+                    <a:lstStyle/>
+                    <a:p>
+                      <a:pPr lvl="0" indent="0" marL="0">
+                        <a:buNone/>
+                      </a:pPr>
+                      <a:r>
+                        <a:rPr>
+                          <a:latin typeface="Courier"/>
+                        </a:rPr>
+                        <a:t>clone</a:t>
+                      </a:r>
+                      <a:r>
+                        <a:rPr/>
+                        <a:t> both models, refit on a split of your own</a:t>
+                      </a:r>
+                    </a:p>
+                  </a:txBody>
+                </a:tc>
+              </a:tr>
+              <a:tr h="0">
+                <a:tc>
+                  <a:txBody>
+                    <a:bodyPr/>
+                    <a:lstStyle/>
+                    <a:p>
+                      <a:pPr lvl="0" indent="0" marL="0">
+                        <a:buNone/>
+                      </a:pPr>
+                      <a:r>
+                        <a:rPr/>
+                        <a:t>scored with</a:t>
+                      </a:r>
+                    </a:p>
+                  </a:txBody>
+                </a:tc>
+                <a:tc>
+                  <a:txBody>
+                    <a:bodyPr/>
+                    <a:lstStyle/>
+                    <a:p>
+                      <a:pPr lvl="0" indent="0" marL="0">
+                        <a:buNone/>
+                      </a:pPr>
+                      <a:r>
+                        <a:rPr>
+                          <a:latin typeface="Courier"/>
+                        </a:rPr>
+                        <a:t>roc_auc_score</a:t>
+                      </a:r>
+                      <a:r>
+                        <a:rPr/>
+                        <a:t> throughout</a:t>
+                      </a:r>
+                    </a:p>
+                  </a:txBody>
+                </a:tc>
+              </a:tr>
+            </a:tbl>
+          </a:graphicData>
+        </a:graphic>
+      </p:graphicFrame>
     </p:spTree>
   </p:cSld>
 </p:sld>

</xml_diff>

<commit_message>
Close the gaps in lesson 2's deck before it is taught
AUC read on the slide that first quotes it, MCAR and MAR spelled out where the
room can see them, the two scalers' formulas, folds explained rather than
assumed, 100:1 built against 110:1 measured, the learning rate named, and the
symbols of the target-encoding identity declared.

Co-Authored-By: Claude Opus 5.5 <noreply@anthropic.com>
</commit_message>
<xml_diff>
--- a/Lessons/02_data_exploration_and_preparation/Slides/data_exploration_and_preparation_slides.pptx
+++ b/Lessons/02_data_exploration_and_preparation/Slides/data_exploration_and_preparation_slides.pptx
@@ -923,7 +923,7 @@
             </a:pPr>
             <a:r>
               <a:rPr/>
-              <a:t>Then the line at the bottom: every option except dropping the column learns a statistic, so all of them belong inside the training fold. That is the thread the whole lesson pulls on.</a:t>
+              <a:t>Then the line at the bottom: every option except dropping the column learns a statistic, so all of them are fitted on the training data only. That is the thread the whole lesson pulls on.</a:t>
             </a:r>
           </a:p>
         </p:txBody>
@@ -2603,6 +2603,20 @@
             </a:pPr>
             <a:r>
               <a:rPr/>
+              <a:t>Say which number is which before anyone asks: the title’s 100:1 is how the two features were built, spreads of 1 and 10; the sample of 1,000 points measures 110:1, which is the figure notebook 2 prints and the toolbox slide quotes.</a:t>
+            </a:r>
+          </a:p>
+          <a:p>
+            <a:pPr lvl="0" indent="0" marL="0">
+              <a:buNone/>
+            </a:pPr>
+          </a:p>
+          <a:p>
+            <a:pPr lvl="0" indent="0" marL="0">
+              <a:buNone/>
+            </a:pPr>
+            <a:r>
+              <a:rPr/>
               <a:t>Left panel: each feature set at its OWN safe rate - standardised still gets there faster, because it tolerates a larger rate. Right panel is the sharper point: give the RAW features the rate the standardised ones handle comfortably and it does not converge slowly, it never converges at all.</a:t>
             </a:r>
           </a:p>
@@ -3305,6 +3319,20 @@
             </a:pPr>
             <a:r>
               <a:rPr/>
+              <a:t>A warning on the letter: k here counts the levels of a category. Slide 16 used k for the z-score cut-off, 3. Same letter, two jobs, both declared in the handout’s notation table - say so out loud once.</a:t>
+            </a:r>
+          </a:p>
+          <a:p>
+            <a:pPr lvl="0" indent="0" marL="0">
+              <a:buNone/>
+            </a:pPr>
+          </a:p>
+          <a:p>
+            <a:pPr lvl="0" indent="0" marL="0">
+              <a:buNone/>
+            </a:pPr>
+            <a:r>
+              <a:rPr/>
               <a:t>This is the encoding to spend time on, because it is what scikit-learn’s OneHotEncoder does and what the pipeline later in the notebook uses.</a:t>
             </a:r>
           </a:p>
@@ -5055,7 +5083,7 @@
             </a:pPr>
             <a:r>
               <a:rPr/>
-              <a:t>Notebook 3 measures the gap. Connect it back to Lesson 1: this is the same independence argument, applied to a step nobody thinks of as learning. The imputer learns; therefore it belongs inside the training fold.</a:t>
+              <a:t>Notebook 3 measures the gap. Connect it back to Lesson 1: this is the same independence argument, applied to a step nobody thinks of as learning. The imputer learns; therefore it is fitted on the training data only.</a:t>
             </a:r>
           </a:p>
         </p:txBody>
@@ -5557,6 +5585,20 @@
         <p:txBody>
           <a:bodyPr/>
           <a:lstStyle/>
+          <a:p>
+            <a:pPr lvl="0" indent="0" marL="0">
+              <a:buNone/>
+            </a:pPr>
+            <a:r>
+              <a:rPr/>
+              <a:t>Name the symbols first, pointing at each: ȳ_c is the churn rate of zip code c over all its customers, row i included; ȳ_c with (−i) is the same rate with row i left out; y_i is row i’s own label; n_c is how many customers zip code c has - not n, the number of features.</a:t>
+            </a:r>
+          </a:p>
+          <a:p>
+            <a:pPr lvl="0" indent="0" marL="0">
+              <a:buNone/>
+            </a:pPr>
+          </a:p>
           <a:p>
             <a:pPr lvl="0" indent="0" marL="0">
               <a:buNone/>
@@ -10116,7 +10158,7 @@
             </a:pPr>
             <a:r>
               <a:rPr/>
-              <a:t>age: MCAR</a:t>
+              <a:t>age: missing completely at random</a:t>
             </a:r>
           </a:p>
         </p:txBody>
@@ -10146,7 +10188,7 @@
             </a:pPr>
             <a:r>
               <a:rPr/>
-              <a:t>Some customers just left it blank. Nothing systematic.</a:t>
+              <a:t>MCAR, for short: some customers just left it blank. Nothing systematic.</a:t>
             </a:r>
           </a:p>
           <a:p>
@@ -10324,7 +10366,7 @@
             </a:pPr>
             <a:r>
               <a:rPr/>
-              <a:t>num_support_calls: MAR</a:t>
+              <a:t>Support calls: missing at random</a:t>
             </a:r>
           </a:p>
         </p:txBody>
@@ -10354,7 +10396,7 @@
             </a:pPr>
             <a:r>
               <a:rPr/>
-              <a:t>Missing more often for long-tenure customers, not by chance.</a:t>
+              <a:t>MAR, for short: missing more often for long-tenure customers - a column we can see explains it.</a:t>
             </a:r>
           </a:p>
           <a:p>
@@ -11954,7 +11996,15 @@
             <a:pPr lvl="0"/>
             <a:r>
               <a:rPr/>
-              <a:t>One step size, along every axis, every iteration. Can it suit both columns?</a:t>
+              <a:t>One step size - the </a:t>
+            </a:r>
+            <a:r>
+              <a:rPr b="1"/>
+              <a:t>learning rate</a:t>
+            </a:r>
+            <a:r>
+              <a:rPr/>
+              <a:t> - along every axis, every iteration. Can it suit both columns?</a:t>
             </a:r>
           </a:p>
         </p:txBody>
@@ -12200,7 +12250,7 @@
             </a:pPr>
             <a:r>
               <a:rPr/>
-              <a:t>Two standard choices, both fitted on training data only.</a:t>
+              <a:t>(x − μ)/σ and (x − min)/(max − min), both fitted on training data only.</a:t>
             </a:r>
           </a:p>
         </p:txBody>
@@ -14073,18 +14123,15 @@
             <a:pPr lvl="0"/>
             <a:r>
               <a:rPr/>
-              <a:t>Baseline: </a:t>
+              <a:t>Accuracy: baseline </a:t>
             </a:r>
             <a:r>
               <a:rPr b="1"/>
               <a:t>0.806</a:t>
             </a:r>
-          </a:p>
-          <a:p>
-            <a:pPr lvl="0"/>
-            <a:r>
-              <a:rPr/>
-              <a:t>Model (numeric + the low-cardinality categoricals, no zip): </a:t>
+            <a:r>
+              <a:rPr/>
+              <a:t>, model </a:t>
             </a:r>
             <a:r>
               <a:rPr b="1"/>
@@ -14092,7 +14139,14 @@
             </a:r>
             <a:r>
               <a:rPr/>
-              <a:t> accuracy, </a:t>
+              <a:t> (numeric + low-cardinality categoricals, no zip)</a:t>
+            </a:r>
+          </a:p>
+          <a:p>
+            <a:pPr lvl="0"/>
+            <a:r>
+              <a:rPr/>
+              <a:t>Area under the receiver operating characteristic curve (AUC): </a:t>
             </a:r>
             <a:r>
               <a:rPr b="1"/>
@@ -14100,7 +14154,7 @@
             </a:r>
             <a:r>
               <a:rPr/>
-              <a:t> AUC (area under the receiver operating characteristic curve)</a:t>
+              <a:t>, the chance a random churner scores above a random non-churner; 0.5 is a coin flip</a:t>
             </a:r>
           </a:p>
           <a:p>
@@ -14127,7 +14181,7 @@
             </a:r>
             <a:r>
               <a:rPr/>
-              <a:t>; AUC from </a:t>
+              <a:t>, </a:t>
             </a:r>
             <a:r>
               <a:rPr>
@@ -14622,7 +14676,7 @@
                       </a:r>
                       <a:r>
                         <a:rPr/>
-                        <a:t>; rate </a:t>
+                        <a:t> (built as 100:1); rate </a:t>
                       </a:r>
                       <a:r>
                         <a:rPr b="1"/>
@@ -15069,11 +15123,11 @@
             </a:r>
             <a:r>
               <a:rPr/>
-              <a:t> fills a gap using </a:t>
+              <a:t> fills a gap with the average of the five most similar rows: its </a:t>
             </a:r>
             <a:r>
               <a:rPr b="1"/>
-              <a:t>other rows’ values</a:t>
+              <a:t>donors</a:t>
             </a:r>
             <a:r>
               <a:rPr/>
@@ -15839,24 +15893,24 @@
             </a:r>
             <a:r>
               <a:rPr/>
-              <a:t>: cross-fitted inside the pipeline.</a:t>
-            </a:r>
-          </a:p>
-          <a:p>
-            <a:pPr lvl="0" indent="0" marL="0">
-              <a:buNone/>
-            </a:pPr>
-            <a:r>
-              <a:rPr/>
-              <a:t>Each row’s encoded value comes from </a:t>
+              <a:t>, inside the pipeline.</a:t>
+            </a:r>
+          </a:p>
+          <a:p>
+            <a:pPr lvl="0" indent="0" marL="0">
+              <a:buNone/>
+            </a:pPr>
+            <a:r>
+              <a:rPr/>
+              <a:t>It splits the training rows into five parts and encodes each row from the </a:t>
             </a:r>
             <a:r>
               <a:rPr b="1"/>
-              <a:t>other</a:t>
-            </a:r>
-            <a:r>
-              <a:rPr/>
-              <a:t> folds, never its own label.</a:t>
+              <a:t>other four</a:t>
+            </a:r>
+            <a:r>
+              <a:rPr/>
+              <a:t>: never from its own label.</a:t>
             </a:r>
           </a:p>
         </p:txBody>
@@ -15946,7 +16000,7 @@
             </a:r>
             <a:r>
               <a:rPr/>
-              <a:t> belongs inside the fold it is fitted on.</a:t>
+              <a:t> is fitted on the training rows only, inside the pipeline.</a:t>
             </a:r>
           </a:p>
           <a:p>

</xml_diff>

<commit_message>
Give lesson 2's missingness indicator the condition its handout measured
The slides said the indicator keeps the MAR signal alive; the handout found it
moves the AUC from 0.751 to 0.741, because tenure_months already carries what it
would. Slides, figure, quiz and the handout's own summary now say it earns its
place only when the gap tells the model something no column does.

Co-Authored-By: Claude Opus 5.5 <noreply@anthropic.com>
</commit_message>
<xml_diff>
--- a/Lessons/02_data_exploration_and_preparation/Slides/data_exploration_and_preparation_slides.pptx
+++ b/Lessons/02_data_exploration_and_preparation/Slides/data_exploration_and_preparation_slides.pptx
@@ -813,7 +813,21 @@
             </a:pPr>
             <a:r>
               <a:rPr/>
-              <a:t>The fix that MCAR imputation does not need: add a binary column recording whether the value was missing. It lets a model use the fact of missingness - which, under MAR, is genuinely informative about tenure - even after the gap itself is filled with a number. Handout Section 3.3.</a:t>
+              <a:t>The predictable answer is “add an indicator, it keeps the MAR signal”, and the reasoning is sound as far as it goes: the gap rows are the long-tenure ones, and they churn at 12.5% against 19.7%, so the fact of the gap is informative.</a:t>
+            </a:r>
+          </a:p>
+          <a:p>
+            <a:pPr lvl="0" indent="0" marL="0">
+              <a:buNone/>
+            </a:pPr>
+          </a:p>
+          <a:p>
+            <a:pPr lvl="0" indent="0" marL="0">
+              <a:buNone/>
+            </a:pPr>
+            <a:r>
+              <a:rPr/>
+              <a:t>But under MAR the gap is explained by a column we already hold - that is the definition - so the model already has what the indicator would tell it. Notebook and handout agree: adding it moves the area under the curve from 0.751 to 0.741, no gain, well inside split-to-split noise. The indicator earns its place when the gap says something no other column does, and that is MNAR. Handout Section 3.3.</a:t>
             </a:r>
           </a:p>
         </p:txBody>
@@ -909,7 +923,7 @@
             </a:pPr>
             <a:r>
               <a:rPr/>
-              <a:t>The one worth dwelling on is the fourth: adding a binary indicator keeps the MAR signal itself available to the model - the fact that long-tenure customers are more often missing a call count may be more informative than the count would have been.</a:t>
+              <a:t>The one worth dwelling on is the fourth, because its usual justification is half right. An indicator keeps the fact of the gap in the table after the gap is filled; that fact only helps if no other column already carries it. Under MCAR it carries nothing; under MAR the column that explains the gap is already there; under MNAR the blank may be the only trace left, and that is where the indicator earns its place.</a:t>
             </a:r>
           </a:p>
           <a:p>
@@ -1019,7 +1033,7 @@
             </a:pPr>
             <a:r>
               <a:rPr/>
-              <a:t>Point out that three of the four branches end somewhere defensible, and that the indicator branch is the one people forget. Adding a column that records that a value was missing costs nothing and keeps the signal alive when the fact of the gap is itself informative - which for anything recorded by a human it usually is.</a:t>
+              <a:t>Point out that three of the four branches end somewhere defensible, and that the indicator branch is the one people reach for by reflex. It is cheap, but it adds information only when the gap tells the model something no other column does: on this dataset it does not, and the area under the curve goes 0.751 to 0.741 with it.</a:t>
             </a:r>
           </a:p>
           <a:p>
@@ -10418,7 +10432,17 @@
             </a:r>
             <a:r>
               <a:rPr/>
-              <a:t> column preserves the signal even after filling</a:t>
+              <a:t> would record the gap - but </a:t>
+            </a:r>
+            <a:r>
+              <a:rPr>
+                <a:latin typeface="Courier"/>
+              </a:rPr>
+              <a:t>tenure_months</a:t>
+            </a:r>
+            <a:r>
+              <a:rPr/>
+              <a:t> already tells the model what the gap would: here it gains nothing</a:t>
             </a:r>
           </a:p>
         </p:txBody>
@@ -10551,7 +10575,7 @@
             </a:r>
             <a:r>
               <a:rPr/>
-              <a:t>: keeps MAR signal alive</a:t>
+              <a:t>: only when the gap says what no other column does - above all when missing not at random (MNAR)</a:t>
             </a:r>
           </a:p>
         </p:txBody>

</xml_diff>

<commit_message>
Say plainly when lesson 2's missingness indicator helps
Co-Authored-By: Claude Opus 5.5 <noreply@anthropic.com>
</commit_message>
<xml_diff>
--- a/Lessons/02_data_exploration_and_preparation/Slides/data_exploration_and_preparation_slides.pptx
+++ b/Lessons/02_data_exploration_and_preparation/Slides/data_exploration_and_preparation_slides.pptx
@@ -827,7 +827,7 @@
             </a:pPr>
             <a:r>
               <a:rPr/>
-              <a:t>But under MAR the gap is explained by a column we already hold - that is the definition - so the model already has what the indicator would tell it. Notebook and handout agree: adding it moves the area under the curve from 0.751 to 0.741, no gain, well inside split-to-split noise. The indicator earns its place when the gap says something no other column does, and that is MNAR. Handout Section 3.3.</a:t>
+              <a:t>But under MAR the gap is explained by a column we already hold - that is the definition - so the model already has what the indicator would tell it. Notebook and handout agree: adding it moves the area under the curve from 0.751 to 0.741, no gain, well inside split-to-split noise. The indicator is worth adding only if being missing tells the model something the other columns cannot - typically when the value is missing not at random (MNAR), because whether it is missing depends on the missing value itself. Handout Section 3.3.</a:t>
             </a:r>
           </a:p>
         </p:txBody>
@@ -10410,14 +10410,14 @@
             </a:pPr>
             <a:r>
               <a:rPr/>
-              <a:t>MAR, for short: missing more often for long-tenure customers - a column we can see explains it.</a:t>
+              <a:t>MAR, for short: long-tenure customers leave it blank more often.</a:t>
             </a:r>
           </a:p>
           <a:p>
             <a:pPr lvl="0"/>
             <a:r>
               <a:rPr/>
-              <a:t>Treating it as MCAR reweights the sample the wrong way</a:t>
+              <a:t>Dropping those rows would remove mostly long-tenure customers</a:t>
             </a:r>
           </a:p>
           <a:p>
@@ -10432,7 +10432,7 @@
             </a:r>
             <a:r>
               <a:rPr/>
-              <a:t> would record the gap - but </a:t>
+              <a:t> (1 if missing, 0 if not) adds nothing here: </a:t>
             </a:r>
             <a:r>
               <a:rPr>
@@ -10442,7 +10442,7 @@
             </a:r>
             <a:r>
               <a:rPr/>
-              <a:t> already tells the model what the gap would: here it gains nothing</a:t>
+              <a:t> already tells the model which rows tend to have a gap</a:t>
             </a:r>
           </a:p>
         </p:txBody>
@@ -10575,7 +10575,15 @@
             </a:r>
             <a:r>
               <a:rPr/>
-              <a:t>: only when the gap says what no other column does - above all when missing not at random (MNAR)</a:t>
+              <a:t>: only if </a:t>
+            </a:r>
+            <a:r>
+              <a:rPr i="1"/>
+              <a:t>being missing</a:t>
+            </a:r>
+            <a:r>
+              <a:rPr/>
+              <a:t> tells the model something the other columns cannot - typically when missing not at random (MNAR)</a:t>
             </a:r>
           </a:p>
         </p:txBody>

</xml_diff>

<commit_message>
Say lesson 2's slides in plain words
Metaphorical titles become statements of what the slide shows, jargon verbs
become what happens to which column, and terms such as churn are explained
where they first appear. Speaker notes are left for a later pass.

Co-Authored-By: Claude Opus 5.5 <noreply@anthropic.com>
</commit_message>
<xml_diff>
--- a/Lessons/02_data_exploration_and_preparation/Slides/data_exploration_and_preparation_slides.pptx
+++ b/Lessons/02_data_exploration_and_preparation/Slides/data_exploration_and_preparation_slides.pptx
@@ -10202,21 +10202,31 @@
             </a:pPr>
             <a:r>
               <a:rPr/>
-              <a:t>MCAR, for short: some customers just left it blank. Nothing systematic.</a:t>
+              <a:t>MCAR, for short: some customers left it blank, for no reason related to any column.</a:t>
             </a:r>
           </a:p>
           <a:p>
             <a:pPr lvl="0"/>
             <a:r>
               <a:rPr/>
-              <a:t>Safe to impute with a fixed statistic</a:t>
+              <a:t>Filling the gaps with the mean leaves the mean of </a:t>
+            </a:r>
+            <a:r>
+              <a:rPr>
+                <a:latin typeface="Courier"/>
+              </a:rPr>
+              <a:t>age</a:t>
+            </a:r>
+            <a:r>
+              <a:rPr/>
+              <a:t> unbiased</a:t>
             </a:r>
           </a:p>
           <a:p>
             <a:pPr lvl="0"/>
             <a:r>
               <a:rPr/>
-              <a:t>The bias question is not “is this fair”: it is “what does filling it cost”</a:t>
+              <a:t>So is filling free? The next slide shows what it costs</a:t>
             </a:r>
           </a:p>
         </p:txBody>
@@ -10298,7 +10308,17 @@
             </a:pPr>
             <a:r>
               <a:rPr/>
-              <a:t>Every correlation involving the imputed column shrinks, even under MCAR.</a:t>
+              <a:t>Filling with the mean weakens every correlation </a:t>
+            </a:r>
+            <a:r>
+              <a:rPr>
+                <a:latin typeface="Courier"/>
+              </a:rPr>
+              <a:t>age</a:t>
+            </a:r>
+            <a:r>
+              <a:rPr/>
+              <a:t> has with other columns, even under MCAR.</a:t>
             </a:r>
           </a:p>
         </p:txBody>
@@ -10717,7 +10737,7 @@
             </a:pPr>
             <a:r>
               <a:rPr/>
-              <a:t>An outlier is far from the rest - not necessarily wrong</a:t>
+              <a:t>Extreme does not mean wrong</a:t>
             </a:r>
           </a:p>
         </p:txBody>
@@ -10793,18 +10813,22 @@
             <a:pPr lvl="0"/>
             <a:r>
               <a:rPr/>
-              <a:t>The arithmetic cannot tell which: 3,344.7 may be a typo or a corporate account</a:t>
+              <a:t>A monthly charge of 3,344.7 may be a typo or a corporate account: the numbers alone cannot tell</a:t>
             </a:r>
           </a:p>
           <a:p>
             <a:pPr lvl="0"/>
             <a:r>
               <a:rPr/>
-              <a:t>Two rules follow - standard deviations, then quartiles - and both only </a:t>
+              <a:t>Two rules follow, one on standard deviations, one on quartiles: both only </a:t>
             </a:r>
             <a:r>
               <a:rPr b="1"/>
               <a:t>flag</a:t>
+            </a:r>
+            <a:r>
+              <a:rPr/>
+              <a:t> a value for a person to check</a:t>
             </a:r>
           </a:p>
         </p:txBody>
@@ -10938,7 +10962,7 @@
             </a:pPr>
             <a:r>
               <a:rPr/>
-              <a:t>Rule 2: distance measured in quartiles</a:t>
+              <a:t>Rule 2: interquartile range (IQR)</a:t>
             </a:r>
           </a:p>
         </p:txBody>
@@ -11020,7 +11044,7 @@
             </a:pPr>
             <a:r>
               <a:rPr/>
-              <a:t>Same neighbourhood, not the same answer</a:t>
+              <a:t>Close fences, very different counts</a:t>
             </a:r>
           </a:p>
         </p:txBody>
@@ -11102,7 +11126,7 @@
             </a:pPr>
             <a:r>
               <a:rPr/>
-              <a:t>The robust rule is the one that got it wrong</a:t>
+              <a:t>Quartile rule: 12 false alarms</a:t>
             </a:r>
           </a:p>
         </p:txBody>
@@ -11243,7 +11267,7 @@
             <a:pPr lvl="0"/>
             <a:r>
               <a:rPr/>
-              <a:t>A show of hands on how you framed it</a:t>
+              <a:t>A show of hands: did you predict a class, or a number?</a:t>
             </a:r>
           </a:p>
         </p:txBody>
@@ -11361,23 +11385,7 @@
             <a:pPr lvl="0"/>
             <a:r>
               <a:rPr/>
-              <a:t>It is not </a:t>
-            </a:r>
-            <a:r>
-              <a:rPr i="1"/>
-              <a:t>unusual</a:t>
-            </a:r>
-            <a:r>
-              <a:rPr/>
-              <a:t>. It is </a:t>
-            </a:r>
-            <a:r>
-              <a:rPr i="1"/>
-              <a:t>invalid</a:t>
-            </a:r>
-            <a:r>
-              <a:rPr/>
-              <a:t>: a different question entirely</a:t>
+              <a:t>It is not unusual, it is impossible: no tenure is negative. Checking validity needs a rule about the domain, not about the distribution</a:t>
             </a:r>
           </a:p>
         </p:txBody>
@@ -11459,7 +11467,7 @@
             </a:pPr>
             <a:r>
               <a:rPr/>
-              <a:t>Detection finds candidates. What to do next is a </a:t>
+              <a:t>The rules only find candidates. What to do with them is decided by someone who knows the </a:t>
             </a:r>
             <a:r>
               <a:rPr b="1"/>
@@ -11467,7 +11475,7 @@
             </a:r>
             <a:r>
               <a:rPr/>
-              <a:t> decision.</a:t>
+              <a:t>.</a:t>
             </a:r>
           </a:p>
           <a:p>
@@ -11478,11 +11486,11 @@
             </a:r>
             <a:r>
               <a:rPr/>
-              <a:t> it at the fence: 3,344.7 becomes 110.0 (</a:t>
+              <a:t> it at the rule’s upper limit: 3,344.7 becomes 110.0 (</a:t>
             </a:r>
             <a:r>
               <a:rPr i="1"/>
-              <a:t>Winsorising</a:t>
+              <a:t>winsorising</a:t>
             </a:r>
             <a:r>
               <a:rPr/>
@@ -12028,7 +12036,7 @@
             <a:pPr lvl="0"/>
             <a:r>
               <a:rPr/>
-              <a:t>One step size - the </a:t>
+              <a:t>The same step size - the </a:t>
             </a:r>
             <a:r>
               <a:rPr b="1"/>
@@ -12036,7 +12044,7 @@
             </a:r>
             <a:r>
               <a:rPr/>
-              <a:t> - along every axis, every iteration. Can it suit both columns?</a:t>
+              <a:t> - is used for every column at every step. Can one size suit both?</a:t>
             </a:r>
           </a:p>
         </p:txBody>
@@ -12088,7 +12096,7 @@
             </a:pPr>
             <a:r>
               <a:rPr/>
-              <a:t>A ravine, not a bowl</a:t>
+              <a:t>Unequal scales: a narrow valley</a:t>
             </a:r>
           </a:p>
         </p:txBody>
@@ -12394,7 +12402,7 @@
             </a:pPr>
             <a:r>
               <a:rPr/>
-              <a:t>A model does arithmetic, and </a:t>
+              <a:t>A model needs numbers, and </a:t>
             </a:r>
             <a:r>
               <a:rPr>
@@ -12404,7 +12412,7 @@
             </a:r>
             <a:r>
               <a:rPr/>
-              <a:t> offers none.</a:t>
+              <a:t> is text: encoding turns it into numbers.</a:t>
             </a:r>
           </a:p>
         </p:txBody>
@@ -12807,7 +12815,7 @@
                       </a:pPr>
                       <a:r>
                         <a:rPr/>
-                        <a:t>simply different: no order, no distances</a:t>
+                        <a:t>all different, none closer to another</a:t>
                       </a:r>
                     </a:p>
                   </a:txBody>
@@ -12913,7 +12921,7 @@
                       </a:pPr>
                       <a:r>
                         <a:rPr/>
-                        <a:t>the level’s own average outcome stands in for it</a:t>
+                        <a:t>replaced by the churn rate of its own category</a:t>
                       </a:r>
                     </a:p>
                   </a:txBody>
@@ -13019,14 +13027,14 @@
             </a:r>
             <a:r>
               <a:rPr/>
-              <a:t>, so the rule is structural, not just discipline</a:t>
+              <a:t>, which enforces that rule in the code instead of relying on memory</a:t>
             </a:r>
           </a:p>
           <a:p>
             <a:pPr lvl="0"/>
             <a:r>
               <a:rPr/>
-              <a:t>Today: apply both to data that is actually messy</a:t>
+              <a:t>Today: both, on messy data - gaps, extreme values, text categories</a:t>
             </a:r>
           </a:p>
         </p:txBody>
@@ -13078,7 +13086,7 @@
             </a:pPr>
             <a:r>
               <a:rPr/>
-              <a:t>Equal steps, unequal meaning</a:t>
+              <a:t>Ordinal: equal steps, unequal churn</a:t>
             </a:r>
           </a:p>
         </p:txBody>
@@ -13160,7 +13168,7 @@
             </a:pPr>
             <a:r>
               <a:rPr/>
-              <a:t>One-hot claims nothing, and pays in columns</a:t>
+              <a:t>One-hot: no order assumed, but wide</a:t>
             </a:r>
           </a:p>
         </p:txBody>
@@ -13188,7 +13196,7 @@
             <a:pPr lvl="0"/>
             <a:r>
               <a:rPr/>
-              <a:t>A column with k levels becomes k binary columns, one 1 per row: </a:t>
+              <a:t>A column with k categories becomes k columns of 0s and 1s, a single 1 per row: </a:t>
             </a:r>
             <a:r>
               <a:rPr>
@@ -13201,7 +13209,7 @@
             <a:pPr lvl="0"/>
             <a:r>
               <a:rPr/>
-              <a:t>It asserts no order and no distance - which is why it is the default</a:t>
+              <a:t>No order between categories, all equally far apart: that is why it is the default</a:t>
             </a:r>
           </a:p>
           <a:p>
@@ -13233,7 +13241,7 @@
             <a:pPr lvl="0"/>
             <a:r>
               <a:rPr/>
-              <a:t>Target encoding compresses any cardinality into one column - computed from the labels, which is where leakage gets in</a:t>
+              <a:t>Target encoding uses one column however many categories there are, but it is computed from the target - which is how leakage gets in</a:t>
             </a:r>
           </a:p>
         </p:txBody>
@@ -13285,7 +13293,7 @@
             </a:pPr>
             <a:r>
               <a:rPr/>
-              <a:t>All k dummies plus an intercept cannot both be free</a:t>
+              <a:t>One one-hot column too many</a:t>
             </a:r>
           </a:p>
         </p:txBody>
@@ -13303,7 +13311,7 @@
         <p:spPr>
           <a:xfrm>
             <a:off x="457200" y="1183005"/>
-            <a:ext cx="8229600" cy="874395"/>
+            <a:ext cx="8229600" cy="1311592"/>
           </a:xfrm>
         </p:spPr>
         <p:txBody>
@@ -13315,7 +13323,7 @@
             </a:pPr>
             <a:r>
               <a:rPr/>
-              <a:t>Most models carry a column of ones - the </a:t>
+              <a:t>Most models include a constant column of ones, the </a:t>
             </a:r>
             <a:r>
               <a:rPr b="1"/>
@@ -13323,7 +13331,15 @@
             </a:r>
             <a:r>
               <a:rPr/>
-              <a:t> - so they can fit a baseline level.</a:t>
+              <a:t>. The k one-hot columns (</a:t>
+            </a:r>
+            <a:r>
+              <a:rPr i="1"/>
+              <a:t>dummies</a:t>
+            </a:r>
+            <a:r>
+              <a:rPr/>
+              <a:t>) also always add up to 1:</a:t>
             </a:r>
           </a:p>
         </p:txBody>
@@ -13344,7 +13360,7 @@
         </p:blipFill>
         <p:spPr bwMode="auto">
           <a:xfrm>
-            <a:off x="457200" y="2401579"/>
+            <a:off x="457200" y="2620178"/>
             <a:ext cx="8229599" cy="1883391"/>
           </a:xfrm>
           <a:prstGeom prst="rect">
@@ -13405,7 +13421,7 @@
             </a:pPr>
             <a:r>
               <a:rPr/>
-              <a:t>Rank deficient by exactly one</a:t>
+              <a:t>4 columns, but only rank 3</a:t>
             </a:r>
           </a:p>
         </p:txBody>
@@ -13542,14 +13558,14 @@
             <a:pPr lvl="0"/>
             <a:r>
               <a:rPr/>
-              <a:t>Distance-based methods (Lesson 6): everything looks equidistant</a:t>
+              <a:t>Methods based on distances (Lesson 6): all points end up roughly equally far apart</a:t>
             </a:r>
           </a:p>
           <a:p>
             <a:pPr lvl="0"/>
             <a:r>
               <a:rPr/>
-              <a:t>More parameters to estimate, same sample size → more variance</a:t>
+              <a:t>More coefficients to estimate from the same 2,000 rows: noisier estimates</a:t>
             </a:r>
           </a:p>
         </p:txBody>
@@ -13683,7 +13699,7 @@
             </a:pPr>
             <a:r>
               <a:rPr/>
-              <a:t>Restating Lesson 1’s argument</a:t>
+              <a:t>Preprocessing is part of f</a:t>
             </a:r>
           </a:p>
         </p:txBody>
@@ -13701,7 +13717,7 @@
         <p:spPr>
           <a:xfrm>
             <a:off x="457200" y="1183005"/>
-            <a:ext cx="8229600" cy="874395"/>
+            <a:ext cx="8229600" cy="1311592"/>
           </a:xfrm>
         </p:spPr>
         <p:txBody>
@@ -13713,7 +13729,7 @@
             </a:pPr>
             <a:r>
               <a:rPr/>
-              <a:t>f includes </a:t>
+              <a:t>f is the whole pipeline: </a:t>
             </a:r>
             <a:r>
               <a:rPr b="1"/>
@@ -13721,7 +13737,7 @@
             </a:r>
             <a:r>
               <a:rPr/>
-              <a:t> learned parameter, not just “the model part”.</a:t>
+              <a:t> number learned from data - the scaler’s means, the imputer’s fill values - not only the model’s coefficients.</a:t>
             </a:r>
           </a:p>
         </p:txBody>
@@ -13742,7 +13758,7 @@
         </p:blipFill>
         <p:spPr bwMode="auto">
           <a:xfrm>
-            <a:off x="1296590" y="2829964"/>
+            <a:off x="1296590" y="3048563"/>
             <a:ext cx="6550819" cy="1026621"/>
           </a:xfrm>
           <a:prstGeom prst="rect">
@@ -14228,7 +14244,7 @@
             </a:pPr>
             <a:r>
               <a:rPr/>
-              <a:t>Modest accuracy gain. Why?</a:t>
+              <a:t>Accuracy barely beats the baseline. Why?</a:t>
             </a:r>
           </a:p>
         </p:txBody>
@@ -14343,7 +14359,7 @@
             <a:pPr lvl="0"/>
             <a:r>
               <a:rPr/>
-              <a:t>Leakage, in a form nothing warns you about</a:t>
+              <a:t>Leakage that raises no error and looks like a good result</a:t>
             </a:r>
           </a:p>
         </p:txBody>
@@ -14507,7 +14523,7 @@
             </a:pPr>
             <a:r>
               <a:rPr/>
-              <a:t>Ratios, interactions, binning: a linear model cannot invent these itself.</a:t>
+              <a:t>New columns built from existing ones, which a linear model cannot build itself.</a:t>
             </a:r>
           </a:p>
           <a:p>
@@ -14522,7 +14538,7 @@
             </a:r>
             <a:r>
               <a:rPr/>
-              <a:t> = charge × months stayed. AUC: 0.7514 → 0.7548, under four thousandths. Clean </a:t>
+              <a:t> = charge × months stayed: AUC 0.7514 → 0.7548. Fix the 999s in </a:t>
             </a:r>
             <a:r>
               <a:rPr>
@@ -14532,7 +14548,7 @@
             </a:r>
             <a:r>
               <a:rPr/>
-              <a:t> first and the same feature scores </a:t>
+              <a:t> first and it scores </a:t>
             </a:r>
             <a:r>
               <a:rPr b="1"/>
@@ -14540,7 +14556,7 @@
             </a:r>
             <a:r>
               <a:rPr/>
-              <a:t> - the gain was living in the 999s.</a:t>
+              <a:t>: the gain came from the errors.</a:t>
             </a:r>
           </a:p>
           <a:p>
@@ -14559,7 +14575,7 @@
             </a:r>
             <a:r>
               <a:rPr/>
-              <a:t>, a step inside the pipeline</a:t>
+              <a:t>, inside the pipeline</a:t>
             </a:r>
           </a:p>
         </p:txBody>
@@ -15172,7 +15188,7 @@
             </a:pPr>
             <a:r>
               <a:rPr/>
-              <a:t>Fit it on train + test, and some of those rows are in the test set.</a:t>
+              <a:t>Fit it on training and test rows together, and some donors are test rows: test information enters the training data.</a:t>
             </a:r>
           </a:p>
         </p:txBody>
@@ -15285,7 +15301,7 @@
             </a:r>
             <a:r>
               <a:rPr/>
-              <a:t>, the imputer’s own metric, names the donors.</a:t>
+              <a:t>, the distance the imputer itself uses, finds the donors.</a:t>
             </a:r>
           </a:p>
           <a:p>
@@ -15476,7 +15492,7 @@
             </a:r>
             <a:r>
               <a:rPr/>
-              <a:t>, computed before anybody has split anything.</a:t>
+              <a:t>, computed on all 2,000 customers, before the split.</a:t>
             </a:r>
           </a:p>
         </p:txBody>
@@ -15610,7 +15626,7 @@
             </a:pPr>
             <a:r>
               <a:rPr/>
-              <a:t>Your own disagreement, divided by your group size</a:t>
+              <a:t>How much of its own label a row sees</a:t>
             </a:r>
           </a:p>
         </p:txBody>
@@ -15730,7 +15746,7 @@
             </a:r>
             <a:r>
               <a:rPr/>
-              <a:t>?</a:t>
+              <a:t> (cancel their contract)?</a:t>
             </a:r>
           </a:p>
           <a:p>
@@ -15744,18 +15760,22 @@
             <a:pPr lvl="0"/>
             <a:r>
               <a:rPr/>
-              <a:t>Categorical: contract type, region, zip code (493 levels)</a:t>
+              <a:t>Categorical: contract type, region, zip code (493 different values)</a:t>
             </a:r>
           </a:p>
           <a:p>
             <a:pPr lvl="0"/>
             <a:r>
               <a:rPr/>
-              <a:t>Missing values, outliers, and one column built to carry </a:t>
+              <a:t>Missing values, extreme values, and one column built to have </a:t>
             </a:r>
             <a:r>
               <a:rPr b="1"/>
-              <a:t>no signal</a:t>
+              <a:t>no relation</a:t>
+            </a:r>
+            <a:r>
+              <a:rPr/>
+              <a:t> to churn</a:t>
             </a:r>
           </a:p>
         </p:txBody>
@@ -16041,7 +16061,7 @@
             </a:pPr>
             <a:r>
               <a:rPr/>
-              <a:t>A mean. A median. A set of neighbours. A per-category average. A set of bin edges.</a:t>
+              <a:t>For example: a mean, a median, the nearest neighbours, a churn rate per category, the edges of bins.</a:t>
             </a:r>
           </a:p>
         </p:txBody>
@@ -16521,7 +16541,7 @@
             <a:pPr lvl="0"/>
             <a:r>
               <a:rPr/>
-              <a:t>Two leaks that look nothing like leaking</a:t>
+              <a:t>Two leaks that raise no error and look like good results</a:t>
             </a:r>
           </a:p>
         </p:txBody>
@@ -16709,7 +16729,7 @@
             <a:pPr lvl="0"/>
             <a:r>
               <a:rPr/>
-              <a:t>Read the handout: the derivations are examinable</a:t>
+              <a:t>Read the handout: it has the derivations behind today’s slides</a:t>
             </a:r>
           </a:p>
           <a:p>
@@ -16813,6 +16833,10 @@
               <a:buNone/>
             </a:pPr>
             <a:r>
+              <a:rPr/>
+              <a:t>First, always: </a:t>
+            </a:r>
+            <a:r>
               <a:rPr>
                 <a:latin typeface="Courier"/>
               </a:rPr>
@@ -16830,21 +16854,21 @@
             </a:r>
             <a:r>
               <a:rPr/>
-              <a:t>, class balance, first: always.</a:t>
+              <a:t>, and the share of each class.</a:t>
             </a:r>
           </a:p>
           <a:p>
             <a:pPr lvl="0"/>
             <a:r>
               <a:rPr/>
-              <a:t>2000 rows, 8 columns, mixed types</a:t>
+              <a:t>2000 rows, 8 columns, numbers and text</a:t>
             </a:r>
           </a:p>
           <a:p>
             <a:pPr lvl="0"/>
             <a:r>
               <a:rPr/>
-              <a:t>Churn rate: </a:t>
+              <a:t>Churn rate </a:t>
             </a:r>
             <a:r>
               <a:rPr b="1"/>
@@ -16852,7 +16876,7 @@
             </a:r>
             <a:r>
               <a:rPr/>
-              <a:t> → baseline accuracy 80.6%</a:t>
+              <a:t>: always predicting “no churn” is right 80.6% of the time</a:t>
             </a:r>
           </a:p>
           <a:p>
@@ -16865,7 +16889,7 @@
             </a:r>
             <a:r>
               <a:rPr/>
-              <a:t> max: 999. Not a typo in the slide.</a:t>
+              <a:t> reaches 999 months, 83 years: an error in the data</a:t>
             </a:r>
           </a:p>
         </p:txBody>
@@ -16917,7 +16941,7 @@
             </a:pPr>
             <a:r>
               <a:rPr/>
-              <a:t>Two of these four have no shape left to read</a:t>
+              <a:t>Outliers squash two of these four</a:t>
             </a:r>
           </a:p>
         </p:txBody>

</xml_diff>

<commit_message>
Say what lesson 2's contour plot is a picture of
The loss as a function of the coefficients, seen from above: lesson 1's search
over one threshold drew it as a curve, two coefficients make it a surface. The
slide, the figure title and the handout now say so, call the step size the
learning rate, and note that only a squared-error loss is exactly a paraboloid.

Co-Authored-By: Claude Opus 5.5 <noreply@anthropic.com>
</commit_message>
<xml_diff>
--- a/Lessons/02_data_exploration_and_preparation/Slides/data_exploration_and_preparation_slides.pptx
+++ b/Lessons/02_data_exploration_and_preparation/Slides/data_exploration_and_preparation_slides.pptx
@@ -2459,6 +2459,20 @@
         <p:txBody>
           <a:bodyPr/>
           <a:lstStyle/>
+          <a:p>
+            <a:pPr lvl="0" indent="0" marL="0">
+              <a:buNone/>
+            </a:pPr>
+            <a:r>
+              <a:rPr/>
+              <a:t>Bridge from Lesson 1 first. Its slide 20 plotted the training error against one number, the threshold t, and the best t was the bottom of that curve. Here the model has two numbers, w1 and w2, so the same average loss becomes a surface over the plane of (w1, w2), and this figure is that surface seen from above: each ring is a contour line, joining coefficient pairs with the same loss. The figure draws an exact paraboloid, the shape of a squared-error loss for a linear model; the logistic loss of the churn model is only approximately this shape, close to its minimum.</a:t>
+            </a:r>
+          </a:p>
+          <a:p>
+            <a:pPr lvl="0" indent="0" marL="0">
+              <a:buNone/>
+            </a:pPr>
+          </a:p>
           <a:p>
             <a:pPr lvl="0" indent="0" marL="0">
               <a:buNone/>
@@ -12018,7 +12032,7 @@
             </a:r>
             <a:r>
               <a:rPr/>
-              <a:t> = choosing the model’s numbers to make Lesson 1’s average loss small</a:t>
+              <a:t>: choose w₁, w₂ to minimise Lesson 1’s average loss, a paraboloid over (w₁, w₂). Lesson 1’s slide 20 drew it for one number, the threshold</a:t>
             </a:r>
           </a:p>
           <a:p>
@@ -12029,14 +12043,7 @@
             </a:r>
             <a:r>
               <a:rPr/>
-              <a:t> does it by repeated small steps downhill on that loss</a:t>
-            </a:r>
-          </a:p>
-          <a:p>
-            <a:pPr lvl="0"/>
-            <a:r>
-              <a:rPr/>
-              <a:t>The same step size - the </a:t>
+              <a:t> walks downhill on it with one step size, the </a:t>
             </a:r>
             <a:r>
               <a:rPr b="1"/>
@@ -12044,7 +12051,7 @@
             </a:r>
             <a:r>
               <a:rPr/>
-              <a:t> - is used for every column at every step. Can one size suit both?</a:t>
+              <a:t>, for every column. Can it suit both?</a:t>
             </a:r>
           </a:p>
         </p:txBody>

</xml_diff>

<commit_message>
Rewrite lesson 2's speaker notes in full
Every note reread against its slide and every number checked against the
notebook outputs and the handout. The indicator's 0.751 to 0.741 comes from
the handout, not a notebook, and the AUC is now glossed where it first appears
in the notes; 493 columns on 2,000 rows is under a quarter, not over; the
bias-variance trade-off is named in lesson 5, not lesson 1; '2000 steps' is
the handout's ten times as long; two slide pointers corrected. The symbols of
slide 36 are read out, smoothing is introduced, and two duplicated notes cut.

Co-Authored-By: Claude Opus 5.5 <noreply@anthropic.com>
</commit_message>
<xml_diff>
--- a/Lessons/02_data_exploration_and_preparation/Slides/data_exploration_and_preparation_slides.pptx
+++ b/Lessons/02_data_exploration_and_preparation/Slides/data_exploration_and_preparation_slides.pptx
@@ -579,7 +579,7 @@
             </a:pPr>
             <a:r>
               <a:rPr/>
-              <a:t>The fifteen minutes on what lesson 1 clarified come before this slide; the exercise discussion follows them, and its part about the ten seeds is easier to discuss right after seeing that a test score is one measurement.</a:t>
+              <a:t>The fifteen minutes going back over what lesson 1 left unclear come before this slide, and the exercise discussion follows them. That order helps: Task 7 of the exercise, the split repeated with ten seeds, is easier to discuss right after seeing again that a test score is one measurement.</a:t>
             </a:r>
           </a:p>
           <a:p>
@@ -689,7 +689,7 @@
             </a:pPr>
             <a:r>
               <a:rPr/>
-              <a:t>Read the curve rather than the formula. Filling gaps with a constant costs correlation, and the cost grows with the fraction filled.</a:t>
+              <a:t>Read the curve rather than the formula. The horizontal axis is the fraction of the column filled with the mean, the vertical axis is how much of the original correlation survives. Filling gaps with a constant costs correlation, and the cost grows with the fraction filled.</a:t>
             </a:r>
           </a:p>
           <a:p>
@@ -731,7 +731,7 @@
             </a:pPr>
             <a:r>
               <a:rPr/>
-              <a:t>The algebra is Handout Section 3.2: the correlation is multiplied by the square root of one minus the missing fraction. Write it on the board if the room wants it - the figure is what they will remember.</a:t>
+              <a:t>The algebra is Handout Section 3.2: filling a fraction p with a constant shrinks the variance to (1 - p) times the original, and multiplies every correlation by the square root of (1 - p). Write it on the board if the room wants it - the figure is what they will remember.</a:t>
             </a:r>
           </a:p>
         </p:txBody>
@@ -827,7 +827,7 @@
             </a:pPr>
             <a:r>
               <a:rPr/>
-              <a:t>But under MAR the gap is explained by a column we already hold - that is the definition - so the model already has what the indicator would tell it. Notebook and handout agree: adding it moves the area under the curve from 0.751 to 0.741, no gain, well inside split-to-split noise. The indicator is worth adding only if being missing tells the model something the other columns cannot - typically when the value is missing not at random (MNAR), because whether it is missing depends on the missing value itself. Handout Section 3.3.</a:t>
+              <a:t>But under MAR the gap is explained by a column we already hold - that is the definition - so the model already has what the indicator would tell it. Handout Section 3.3 measures it: adding the indicator moves the area under the receiver operating characteristic curve (AUC) from 0.751 to 0.741 - no gain, well inside split-to-split noise. The AUC is defined on slide 39; for now, higher is better and 0.5 is a coin flip. The indicator is worth adding only if being missing tells the model something the other columns cannot - typically when the value is missing not at random (MNAR), because whether it is missing depends on the missing value itself. Handout Section 3.3.</a:t>
             </a:r>
           </a:p>
         </p:txBody>
@@ -2673,7 +2673,7 @@
             </a:pPr>
             <a:r>
               <a:rPr/>
-              <a:t>Be precise about the failure if anyone asks, because “diverges” is the word people reach for and it is not what this is. The loss does not climb away to infinity - it swings between 0.69 and 8.29 and stays there, bouncing from one side of the valley to the other. Run it for 2000 steps and it is still in the same band. Worse than slow: a slow run at least finishes.</a:t>
+              <a:t>Be precise about the failure if anyone asks, because “diverges” is the word people reach for and it is not what this is. The loss does not climb away to infinity - it swings between 0.69 and 8.29 and stays there, bouncing from one side of the valley to the other. Run it ten times as long and it is still in the same band. Worse than slow: a slow run at least finishes.</a:t>
             </a:r>
           </a:p>
           <a:p>
@@ -3279,7 +3279,7 @@
             </a:pPr>
             <a:r>
               <a:rPr/>
-              <a:t>Timing: roughly 25 minutes to the first notebook, then a break, then scaling and encoding, then the leakage section closes the lesson before homework.</a:t>
+              <a:t>Timing: about 25 minutes of slides (6 to 21) before the first notebook, then a break, then scaling and encoding, then the leakage section closes the lesson before homework.</a:t>
             </a:r>
           </a:p>
         </p:txBody>
@@ -3403,7 +3403,7 @@
             </a:pPr>
             <a:r>
               <a:rPr/>
-              <a:t>Then the cost, which is the honest trade: k columns. Three is nothing; 493 on 2,000 rows is the curse of dimensionality, two slides from here.</a:t>
+              <a:t>Then the cost, which is the honest trade: k columns. Three is nothing; 493 on 2,000 rows is the curse of dimensionality, on slide 34.</a:t>
             </a:r>
           </a:p>
           <a:p>
@@ -3817,21 +3817,21 @@
             </a:pPr>
             <a:r>
               <a:rPr/>
-              <a:t>The number to dwell on: one-hot encoding zip_code produces 493 columns, almost all zero, on 2000 rows. More columns than a quarter of the sample size, for one field.</a:t>
-            </a:r>
-          </a:p>
-          <a:p>
-            <a:pPr lvl="0" indent="0" marL="0">
-              <a:buNone/>
-            </a:pPr>
-          </a:p>
-          <a:p>
-            <a:pPr lvl="0" indent="0" marL="0">
-              <a:buNone/>
-            </a:pPr>
-            <a:r>
-              <a:rPr/>
-              <a:t>Two consequences to name. Distance-based methods (Lesson 6) degrade, because in high dimensions everything becomes roughly equidistant from everything else. And every column is a parameter to estimate from the same fixed amount of data, which is the bias-variance trade-off from Lesson 1 arriving from a new direction.</a:t>
+              <a:t>The number to dwell on: one-hot encoding zip_code produces 493 columns, almost all zero, on 2000 rows - one new column for every four rows, from a single field.</a:t>
+            </a:r>
+          </a:p>
+          <a:p>
+            <a:pPr lvl="0" indent="0" marL="0">
+              <a:buNone/>
+            </a:pPr>
+          </a:p>
+          <a:p>
+            <a:pPr lvl="0" indent="0" marL="0">
+              <a:buNone/>
+            </a:pPr>
+            <a:r>
+              <a:rPr/>
+              <a:t>Two consequences to name. Distance-based methods (Lesson 6) degrade, because in high dimensions everything becomes roughly equidistant from everything else. And every column is a parameter to estimate from the same fixed amount of data, so the estimates get noisier: the overfitting gap of lesson 1 (slide 21) arriving from a new direction. Lesson 5 names it the bias-variance trade-off.</a:t>
             </a:r>
           </a:p>
         </p:txBody>
@@ -4009,7 +4009,21 @@
             </a:pPr>
             <a:r>
               <a:rPr/>
-              <a:t>Say the condition out loud, because it is not written on the slide and it is the whole content: this equality holds ONLY IF f is independent of T.</a:t>
+              <a:t>Read the symbols first: T is the test set, m rows drawn from the distribution D; R-hat of T is the average loss on those rows; R is the expected risk from lesson 1. The equation says that, averaged over all the test sets we might have drawn, the test score equals the true risk.</a:t>
+            </a:r>
+          </a:p>
+          <a:p>
+            <a:pPr lvl="0" indent="0" marL="0">
+              <a:buNone/>
+            </a:pPr>
+          </a:p>
+          <a:p>
+            <a:pPr lvl="0" indent="0" marL="0">
+              <a:buNone/>
+            </a:pPr>
+            <a:r>
+              <a:rPr/>
+              <a:t>Then say the condition out loud, because it is not written on the slide and it is the whole content: this equality holds ONLY IF f is independent of T.</a:t>
             </a:r>
           </a:p>
           <a:p>
@@ -4037,7 +4051,7 @@
             </a:pPr>
             <a:r>
               <a:rPr/>
-              <a:t>The moment any of those parameters - a mean, a set of neighbours, a per-category average - is estimated using rows that later appear in T, f is no longer independent of T, and the equality breaks. This is the one-sentence version of everything Section 9 is about to demonstrate concretely.</a:t>
+              <a:t>The moment any of those parameters - a mean, a set of neighbours, a per-category average - is estimated using rows that later appear in T, f is no longer independent of T, and the equality breaks. This is the one-sentence version of everything handout Section 9, and the leakage section of today’s slides, are about to demonstrate concretely.</a:t>
             </a:r>
           </a:p>
         </p:txBody>
@@ -4215,7 +4229,7 @@
             </a:pPr>
             <a:r>
               <a:rPr/>
-              <a:t>Say out loud what the five short names stand for, or someone spends the next minute working it out instead of listening: num_pipe and cat_pipe are the impute-then-transform pairs from the diagram two slides back, num_cols and cat_cols are plain lists of column names, and clf is the classifier. They are abbreviated here only to fit the slide - handout Section 8.2 prints the same block with full names, every import, and both column lists, and it runs as printed.</a:t>
+              <a:t>Say out loud what the five short names stand for, or someone spends the next minute working it out instead of listening: num_pipe and cat_pipe are the impute-then-transform pairs from the diagram on the previous slide, num_cols and cat_cols are plain lists of column names, and clf is the classifier. They are abbreviated here only to fit the slide - handout Section 8.2 prints the same block with full names, every import, and both column lists, and it runs as printed.</a:t>
             </a:r>
           </a:p>
           <a:p>
@@ -5015,7 +5029,7 @@
             </a:pPr>
             <a:r>
               <a:rPr/>
-              <a:t>Set up the closing section. Lesson 1’s leak - selecting features on the full dataset - is visible once you know to look for it: an obviously extra step. Today’s two are not. Imputing a missing value and encoding a category both read as ordinary data cleaning, not as “training a model.” They ARE training a model, in the sense Section 8.1 makes precise: any fitted parameter is part of f, and f must be independent of the test set.</a:t>
+              <a:t>Set up the closing section. Lesson 1’s leak - selecting features on the full dataset - is visible once you know to look for it: an obviously extra step. Today’s two are not. Imputing a missing value and encoding a category both read as ordinary data cleaning, not as “training a model.” They ARE training a model, in the sense handout Section 8.1 makes precise and slide 36 stated: any fitted parameter is part of f, and f must be independent of the test set.</a:t>
             </a:r>
           </a:p>
         </p:txBody>
@@ -5785,7 +5799,7 @@
             </a:pPr>
             <a:r>
               <a:rPr/>
-              <a:t>Connect to Section 6.3: high cardinality means small groups means a bigger leak by exactly this formula - the curse of dimensionality and the leakage risk are the same underlying fact.</a:t>
+              <a:t>Connect to handout Section 6.3 and slide 34: a column with many levels (high cardinality) has few rows per level, and by this formula few rows per level means a bigger leak. The width problem of one-hot encoding and the leak of target encoding come from the same fact: many levels, few rows in each.</a:t>
             </a:r>
           </a:p>
         </p:txBody>
@@ -5963,7 +5977,7 @@
             </a:pPr>
             <a:r>
               <a:rPr/>
-              <a:t>Smoothing pulls each group’s mean towards the global mean, weighted by group size, so a one-customer zip code barely moves from the overall rate. It reduces the leak but does not remove it.</a:t>
+              <a:t>TargetEncoder also applies smoothing: it pulls each group’s churn rate towards the overall churn rate, the more so the smaller the group, so a one-customer zip code barely moves from the overall rate. Smoothing reduces the leak but does not remove it.</a:t>
             </a:r>
           </a:p>
           <a:p>
@@ -6527,35 +6541,21 @@
             </a:pPr>
             <a:r>
               <a:rPr/>
-              <a:t>Set the exercise explicitly and say when it is discussed - the first ten minutes of Lesson 3, Friday 16 October.</a:t>
-            </a:r>
-          </a:p>
-          <a:p>
-            <a:pPr lvl="0" indent="0" marL="0">
-              <a:buNone/>
-            </a:pPr>
-          </a:p>
-          <a:p>
-            <a:pPr lvl="0" indent="0" marL="0">
-              <a:buNone/>
-            </a:pPr>
-            <a:r>
-              <a:rPr/>
-              <a:t>Point out that it uses the same churn dataset, so the exploration they did today carries over, and that what counts is again methodology: a pipeline that is correct but modest beats a better score obtained by preparing the full dataset before splitting.</a:t>
-            </a:r>
-          </a:p>
-          <a:p>
-            <a:pPr lvl="0" indent="0" marL="0">
-              <a:buNone/>
-            </a:pPr>
-          </a:p>
-          <a:p>
-            <a:pPr lvl="0" indent="0" marL="0">
-              <a:buNone/>
-            </a:pPr>
-            <a:r>
-              <a:rPr/>
-              <a:t>Remind them that nothing is handed in: every exercise is kept, because one of the ten is drawn at the exam and discussed from their own notebook.</a:t>
+              <a:t>The checklist for the week. The exercise was set on the previous slide; say once more that it is discussed at the start of Lesson 3, Friday 16 October.</a:t>
+            </a:r>
+          </a:p>
+          <a:p>
+            <a:pPr lvl="0" indent="0" marL="0">
+              <a:buNone/>
+            </a:pPr>
+          </a:p>
+          <a:p>
+            <a:pPr lvl="0" indent="0" marL="0">
+              <a:buNone/>
+            </a:pPr>
+            <a:r>
+              <a:rPr/>
+              <a:t>Point out that it uses the same churn generator, so the exploration they did today carries over, and that what counts is again methodology: a pipeline that is correct but modest beats a better score obtained by preparing the full dataset before splitting.</a:t>
             </a:r>
           </a:p>
         </p:txBody>
@@ -6665,7 +6665,7 @@
             </a:pPr>
             <a:r>
               <a:rPr/>
-              <a:t>Then point at age and num_support_calls, which are on their own honest ranges and do show a distribution - age skewed with a spike at the youngest bound, support calls a Poisson-looking count. That contrast is the argument for cleaning before looking any further, and it is why the same plot reappears after Section 4.</a:t>
+              <a:t>Then point at age and num_support_calls, which are on their own honest ranges and do show a distribution - age skewed with a spike at the youngest bound, support calls a Poisson-looking count. That contrast is the argument for cleaning before looking any further, and it is why the same plot reappears in the handout after Section 4 has cleaned the outliers.</a:t>
             </a:r>
           </a:p>
         </p:txBody>
@@ -6995,21 +6995,7 @@
             </a:pPr>
             <a:r>
               <a:rPr/>
-              <a:t>The answer is no, and the reason is that a column is never used alone. Handout Section 3.2 derives it: filling p of the entries with a constant shrinks the variance to (1-p) times the original, and attenuates every correlation the column has with anything else by the square root of (1-p).</a:t>
-            </a:r>
-          </a:p>
-          <a:p>
-            <a:pPr lvl="0" indent="0" marL="0">
-              <a:buNone/>
-            </a:pPr>
-          </a:p>
-          <a:p>
-            <a:pPr lvl="0" indent="0" marL="0">
-              <a:buNone/>
-            </a:pPr>
-            <a:r>
-              <a:rPr/>
-              <a:t>Have the numbers ready. For age at p = 0.08 the factor is 0.96 - small enough to ignore. At p = 0.4 it is 0.77, which erases nearly a quarter of a genuine relationship. Tell them the practical rule that follows: mean imputation is fine when the gaps are few, and quietly destructive when they are many.</a:t>
+              <a:t>The answer is no, and the reason is that a column is never used alone: filling the gaps with one constant value weakens every correlation the column has with anything else. The next slide shows by how much.</a:t>
             </a:r>
           </a:p>
         </p:txBody>

</xml_diff>

<commit_message>
Draw lesson 2's imputation leak as 94 and 34 of 128
The figure on slide 46 drew the 128 imputed rows as a grey bar under the
red 94 and labelled the grey "rows with age imputed", so the visible grey
stub read as 34 imputed rows. The bar is now two adjacent segments, 94
with a test-set donor and 34 with only training donors, under a bracket
carrying the 128. Regenerated in the container.

Co-Authored-By: Claude Opus 5.5 <noreply@anthropic.com>
</commit_message>
<xml_diff>
--- a/Lessons/02_data_exploration_and_preparation/Slides/data_exploration_and_preparation_slides.pptx
+++ b/Lessons/02_data_exploration_and_preparation/Slides/data_exploration_and_preparation_slides.pptx
@@ -15390,8 +15390,8 @@
         </p:blipFill>
         <p:spPr bwMode="auto">
           <a:xfrm>
-            <a:off x="457201" y="1176140"/>
-            <a:ext cx="8229597" cy="3340099"/>
+            <a:off x="909780" y="1166099"/>
+            <a:ext cx="7324439" cy="3360181"/>
           </a:xfrm>
           <a:prstGeom prst="rect">
             <a:avLst/>

</xml_diff>

<commit_message>
Draw lesson 2's leaks in notebook 3, from the numbers it computes
The 94-of-128 bar moves from make_figures.py, where 128 and 94 were typed
in, to a cell after the donor count that draws it from the count, so the
figure students see on slide 46 is now the one their notebook produces.
Two figures join it in the notebook only: the twenty leaky-minus-honest
AUC gaps on both sides of zero, with the main split's +0.0007 among them,
and the customers by zip-code size beside the 1/n_c share of their own
label, 45 alone and 23.8% in groups of three or fewer. Re-run in the
container; every other output and figure is unchanged.

Co-Authored-By: Claude Opus 5.5 <noreply@anthropic.com>
</commit_message>
<xml_diff>
--- a/Lessons/02_data_exploration_and_preparation/Slides/data_exploration_and_preparation_slides.pptx
+++ b/Lessons/02_data_exploration_and_preparation/Slides/data_exploration_and_preparation_slides.pptx
@@ -15390,8 +15390,8 @@
         </p:blipFill>
         <p:spPr bwMode="auto">
           <a:xfrm>
-            <a:off x="909780" y="1166099"/>
-            <a:ext cx="7324439" cy="3360181"/>
+            <a:off x="941243" y="1166099"/>
+            <a:ext cx="7261514" cy="3360181"/>
           </a:xfrm>
           <a:prstGeom prst="rect">
             <a:avLst/>

</xml_diff>